<commit_message>
feat: use direct CGU connections and remove localhost helper
</commit_message>
<xml_diff>
--- a/docs/PaperReader_使用指引.pptx
+++ b/docs/PaperReader_使用指引.pptx
@@ -2,24 +2,24 @@
 <file path=ppt/presentation.xml><?xml version="1.0" encoding="utf-8"?>
 <p:presentation xmlns:p="http://schemas.openxmlformats.org/presentationml/2006/main">
   <p:sldMasterIdLst>
-    <p:sldMasterId xmlns:r="http://schemas.openxmlformats.org/officeDocument/2006/relationships" id="2147483648" r:id="R92ec380b632240ca"/>
+    <p:sldMasterId xmlns:r="http://schemas.openxmlformats.org/officeDocument/2006/relationships" id="2147483648" r:id="R7e945b6cb6bd463a"/>
   </p:sldMasterIdLst>
   <p:notesMasterIdLst>
-    <p:notesMasterId xmlns:r="http://schemas.openxmlformats.org/officeDocument/2006/relationships" r:id="R3fa57cff972144ee"/>
+    <p:notesMasterId xmlns:r="http://schemas.openxmlformats.org/officeDocument/2006/relationships" r:id="Rfa52d44d88f941c8"/>
   </p:notesMasterIdLst>
   <p:sldIdLst>
-    <p:sldId xmlns:r="http://schemas.openxmlformats.org/officeDocument/2006/relationships" id="256" r:id="R530c0ef5e6864bbf"/>
-    <p:sldId xmlns:r="http://schemas.openxmlformats.org/officeDocument/2006/relationships" id="257" r:id="R3c8746797cb947fa"/>
-    <p:sldId xmlns:r="http://schemas.openxmlformats.org/officeDocument/2006/relationships" id="258" r:id="Ra36a28aeb99b4308"/>
-    <p:sldId xmlns:r="http://schemas.openxmlformats.org/officeDocument/2006/relationships" id="259" r:id="Rcbc68d211bde421b"/>
-    <p:sldId xmlns:r="http://schemas.openxmlformats.org/officeDocument/2006/relationships" id="260" r:id="R96caae2c4258469b"/>
-    <p:sldId xmlns:r="http://schemas.openxmlformats.org/officeDocument/2006/relationships" id="261" r:id="Rdd130b177f8e4033"/>
-    <p:sldId xmlns:r="http://schemas.openxmlformats.org/officeDocument/2006/relationships" id="262" r:id="R7e92400465304b10"/>
-    <p:sldId xmlns:r="http://schemas.openxmlformats.org/officeDocument/2006/relationships" id="263" r:id="R035a63a08c524e44"/>
-    <p:sldId xmlns:r="http://schemas.openxmlformats.org/officeDocument/2006/relationships" id="264" r:id="R77cf9c2d1fcd4927"/>
-    <p:sldId xmlns:r="http://schemas.openxmlformats.org/officeDocument/2006/relationships" id="265" r:id="R189c42a7fde947fb"/>
-    <p:sldId xmlns:r="http://schemas.openxmlformats.org/officeDocument/2006/relationships" id="266" r:id="R364908a1ceee4871"/>
-    <p:sldId xmlns:r="http://schemas.openxmlformats.org/officeDocument/2006/relationships" id="267" r:id="R04a36f0b32e14b81"/>
+    <p:sldId xmlns:r="http://schemas.openxmlformats.org/officeDocument/2006/relationships" id="256" r:id="Rbb466c96047d41f7"/>
+    <p:sldId xmlns:r="http://schemas.openxmlformats.org/officeDocument/2006/relationships" id="257" r:id="R2aef927ad5ec4c61"/>
+    <p:sldId xmlns:r="http://schemas.openxmlformats.org/officeDocument/2006/relationships" id="258" r:id="R4689679d41454e37"/>
+    <p:sldId xmlns:r="http://schemas.openxmlformats.org/officeDocument/2006/relationships" id="259" r:id="Rb3424b762ccf43dc"/>
+    <p:sldId xmlns:r="http://schemas.openxmlformats.org/officeDocument/2006/relationships" id="260" r:id="R7782d02ef5ed4a2d"/>
+    <p:sldId xmlns:r="http://schemas.openxmlformats.org/officeDocument/2006/relationships" id="261" r:id="Rce97334dd29d4a11"/>
+    <p:sldId xmlns:r="http://schemas.openxmlformats.org/officeDocument/2006/relationships" id="262" r:id="R305e589ea1d44ce9"/>
+    <p:sldId xmlns:r="http://schemas.openxmlformats.org/officeDocument/2006/relationships" id="263" r:id="Rc5f70c8f19984fd7"/>
+    <p:sldId xmlns:r="http://schemas.openxmlformats.org/officeDocument/2006/relationships" id="264" r:id="R765291e5cc87433c"/>
+    <p:sldId xmlns:r="http://schemas.openxmlformats.org/officeDocument/2006/relationships" id="265" r:id="R302ae29599d748c4"/>
+    <p:sldId xmlns:r="http://schemas.openxmlformats.org/officeDocument/2006/relationships" id="266" r:id="Rc7f0303df4064b8e"/>
+    <p:sldId xmlns:r="http://schemas.openxmlformats.org/officeDocument/2006/relationships" id="267" r:id="R8867257c4ea34a08"/>
   </p:sldIdLst>
   <p:sldSz cx="15240000" cy="8572500"/>
   <p:notesSz cx="6858000" cy="9144000"/>
@@ -453,7 +453,7 @@
           <a:lstStyle xmlns:a="http://schemas.openxmlformats.org/drawingml/2006/main"/>
           <a:p xmlns:a="http://schemas.openxmlformats.org/drawingml/2006/main">
             <a:r>
-              <a:t>PaperReader 線上網站：https://educatres.github.io/PaperReader/。本指引使用內建的原創教學 PDF。實作依據為 97c5833。</a:t>
+              <a:t>PaperReader 線上網站：https://educatres.github.io/PaperReader/。本指引使用內建的原創教學 PDF。已更新 CGU 瀏覽器直接連線流程（2026-10-19）。</a:t>
             </a:r>
           </a:p>
         </p:txBody>
@@ -523,7 +523,7 @@
           <a:lstStyle xmlns:a="http://schemas.openxmlformats.org/drawingml/2006/main"/>
           <a:p xmlns:a="http://schemas.openxmlformats.org/drawingml/2006/main">
             <a:r>
-              <a:t>PaperReader 操作說明，依 97c5833 版本。</a:t>
+              <a:t>PaperReader 操作說明，已更新 CGU 瀏覽器直接連線流程（2026-10-19）。</a:t>
             </a:r>
           </a:p>
           <a:p xmlns:a="http://schemas.openxmlformats.org/drawingml/2006/main">
@@ -608,7 +608,7 @@
           <a:lstStyle xmlns:a="http://schemas.openxmlformats.org/drawingml/2006/main"/>
           <a:p xmlns:a="http://schemas.openxmlformats.org/drawingml/2006/main">
             <a:r>
-              <a:t>PaperReader 操作說明，依 97c5833 版本。</a:t>
+              <a:t>PaperReader 操作說明，已更新 CGU 瀏覽器直接連線流程（2026-10-19）。</a:t>
             </a:r>
           </a:p>
           <a:p xmlns:a="http://schemas.openxmlformats.org/drawingml/2006/main">
@@ -693,7 +693,7 @@
           <a:lstStyle xmlns:a="http://schemas.openxmlformats.org/drawingml/2006/main"/>
           <a:p xmlns:a="http://schemas.openxmlformats.org/drawingml/2006/main">
             <a:r>
-              <a:t>PaperReader 操作說明，依 97c5833 版本。</a:t>
+              <a:t>PaperReader 操作說明，已更新 CGU 瀏覽器直接連線流程（2026-10-19）。</a:t>
             </a:r>
           </a:p>
           <a:p xmlns:a="http://schemas.openxmlformats.org/drawingml/2006/main">
@@ -778,7 +778,7 @@
           <a:lstStyle xmlns:a="http://schemas.openxmlformats.org/drawingml/2006/main"/>
           <a:p xmlns:a="http://schemas.openxmlformats.org/drawingml/2006/main">
             <a:r>
-              <a:t>PaperReader 操作說明，依 97c5833 版本。</a:t>
+              <a:t>PaperReader 操作說明，已更新 CGU 瀏覽器直接連線流程（2026-10-19）。</a:t>
             </a:r>
           </a:p>
           <a:p xmlns:a="http://schemas.openxmlformats.org/drawingml/2006/main">
@@ -863,7 +863,7 @@
           <a:lstStyle xmlns:a="http://schemas.openxmlformats.org/drawingml/2006/main"/>
           <a:p xmlns:a="http://schemas.openxmlformats.org/drawingml/2006/main">
             <a:r>
-              <a:t>PaperReader 操作說明，依 97c5833 版本。</a:t>
+              <a:t>PaperReader 操作說明，已更新 CGU 瀏覽器直接連線流程（2026-10-19）。</a:t>
             </a:r>
           </a:p>
           <a:p xmlns:a="http://schemas.openxmlformats.org/drawingml/2006/main">
@@ -948,7 +948,7 @@
           <a:lstStyle xmlns:a="http://schemas.openxmlformats.org/drawingml/2006/main"/>
           <a:p xmlns:a="http://schemas.openxmlformats.org/drawingml/2006/main">
             <a:r>
-              <a:t>PaperReader 操作說明，依 97c5833 版本。</a:t>
+              <a:t>PaperReader 操作說明，已更新 CGU 瀏覽器直接連線流程（2026-10-19）。</a:t>
             </a:r>
           </a:p>
           <a:p xmlns:a="http://schemas.openxmlformats.org/drawingml/2006/main">
@@ -1033,7 +1033,7 @@
           <a:lstStyle xmlns:a="http://schemas.openxmlformats.org/drawingml/2006/main"/>
           <a:p xmlns:a="http://schemas.openxmlformats.org/drawingml/2006/main">
             <a:r>
-              <a:t>PaperReader 操作說明，依 97c5833 版本。</a:t>
+              <a:t>PaperReader 操作說明，已更新 CGU 瀏覽器直接連線流程（2026-10-19）。</a:t>
             </a:r>
           </a:p>
           <a:p xmlns:a="http://schemas.openxmlformats.org/drawingml/2006/main">
@@ -1118,7 +1118,7 @@
           <a:lstStyle xmlns:a="http://schemas.openxmlformats.org/drawingml/2006/main"/>
           <a:p xmlns:a="http://schemas.openxmlformats.org/drawingml/2006/main">
             <a:r>
-              <a:t>PaperReader 操作說明，依 97c5833 版本。</a:t>
+              <a:t>PaperReader 操作說明，已更新 CGU 瀏覽器直接連線流程（2026-10-19）。</a:t>
             </a:r>
           </a:p>
           <a:p xmlns:a="http://schemas.openxmlformats.org/drawingml/2006/main">
@@ -1203,12 +1203,12 @@
           <a:lstStyle xmlns:a="http://schemas.openxmlformats.org/drawingml/2006/main"/>
           <a:p xmlns:a="http://schemas.openxmlformats.org/drawingml/2006/main">
             <a:r>
-              <a:t>PaperReader 操作說明，依 97c5833 版本。</a:t>
+              <a:t>PaperReader 操作說明，已更新 CGU 瀏覽器直接連線流程（2026-10-19）。</a:t>
             </a:r>
           </a:p>
           <a:p xmlns:a="http://schemas.openxmlformats.org/drawingml/2006/main">
             <a:r>
-              <a:t>來源：README.md CGU 連線、public/PaperReader-CGU-Bridge.mjs、06-cgu.png</a:t>
+              <a:t>來源：README.md CGU 連線、src/components/Settings.tsx、06-cgu.png</a:t>
             </a:r>
           </a:p>
           <a:p xmlns:a="http://schemas.openxmlformats.org/drawingml/2006/main">
@@ -1288,7 +1288,7 @@
           <a:lstStyle xmlns:a="http://schemas.openxmlformats.org/drawingml/2006/main"/>
           <a:p xmlns:a="http://schemas.openxmlformats.org/drawingml/2006/main">
             <a:r>
-              <a:t>PaperReader 操作說明，依 97c5833 版本。</a:t>
+              <a:t>PaperReader 操作說明，已更新 CGU 瀏覽器直接連線流程（2026-10-19）。</a:t>
             </a:r>
           </a:p>
           <a:p xmlns:a="http://schemas.openxmlformats.org/drawingml/2006/main">
@@ -1373,7 +1373,7 @@
           <a:lstStyle xmlns:a="http://schemas.openxmlformats.org/drawingml/2006/main"/>
           <a:p xmlns:a="http://schemas.openxmlformats.org/drawingml/2006/main">
             <a:r>
-              <a:t>PaperReader 操作說明，依 97c5833 版本。</a:t>
+              <a:t>PaperReader 操作說明，已更新 CGU 瀏覽器直接連線流程（2026-10-19）。</a:t>
             </a:r>
           </a:p>
           <a:p xmlns:a="http://schemas.openxmlformats.org/drawingml/2006/main">
@@ -1435,7 +1435,7 @@
           <p:cNvPr id="3" name="Title">
             <a:extLst xmlns:a="http://schemas.openxmlformats.org/drawingml/2006/main">
               <a:ext uri="{FF2B5EF4-FFF2-40B4-BE49-F238E27FC236}">
-                <a16:creationId xmlns:a16="http://schemas.microsoft.com/office/drawing/2014/main" id="{907BD6D9-2ADB-4DB0-BDF4-E17BE92193C1}"/>
+                <a16:creationId xmlns:a16="http://schemas.microsoft.com/office/drawing/2014/main" id="{C543D151-10AD-4C44-8845-E35770EC4DBC}"/>
               </a:ext>
             </a:extLst>
           </p:cNvPr>
@@ -1664,7 +1664,7 @@
           <p:cNvPr id="2" name="Subtitle">
             <a:extLst xmlns:a="http://schemas.openxmlformats.org/drawingml/2006/main">
               <a:ext uri="{FF2B5EF4-FFF2-40B4-BE49-F238E27FC236}">
-                <a16:creationId xmlns:a16="http://schemas.microsoft.com/office/drawing/2014/main" id="{0F335AD2-BF46-43EB-B01A-76CB524F7C3C}"/>
+                <a16:creationId xmlns:a16="http://schemas.microsoft.com/office/drawing/2014/main" id="{97CEB74D-0C69-4A82-8123-95FE8331600D}"/>
               </a:ext>
             </a:extLst>
           </p:cNvPr>
@@ -1910,7 +1910,7 @@
           <p:cNvPr id="2" name="Section title">
             <a:extLst xmlns:a="http://schemas.openxmlformats.org/drawingml/2006/main">
               <a:ext uri="{FF2B5EF4-FFF2-40B4-BE49-F238E27FC236}">
-                <a16:creationId xmlns:a16="http://schemas.microsoft.com/office/drawing/2014/main" id="{18F30C16-004F-4D14-9A1F-2C318B4EE907}"/>
+                <a16:creationId xmlns:a16="http://schemas.microsoft.com/office/drawing/2014/main" id="{E3FFFD07-DBEB-423D-971D-D77D6932713D}"/>
               </a:ext>
             </a:extLst>
           </p:cNvPr>
@@ -2156,7 +2156,7 @@
           <p:cNvPr id="3" name="Title">
             <a:extLst xmlns:a="http://schemas.openxmlformats.org/drawingml/2006/main">
               <a:ext uri="{FF2B5EF4-FFF2-40B4-BE49-F238E27FC236}">
-                <a16:creationId xmlns:a16="http://schemas.microsoft.com/office/drawing/2014/main" id="{DFDC01E8-C724-4C8C-9DD7-651DA0B37BD6}"/>
+                <a16:creationId xmlns:a16="http://schemas.microsoft.com/office/drawing/2014/main" id="{C0F9D50B-29D5-4680-AABE-743245431184}"/>
               </a:ext>
             </a:extLst>
           </p:cNvPr>
@@ -2385,7 +2385,7 @@
           <p:cNvPr id="2" name="Body">
             <a:extLst xmlns:a="http://schemas.openxmlformats.org/drawingml/2006/main">
               <a:ext uri="{FF2B5EF4-FFF2-40B4-BE49-F238E27FC236}">
-                <a16:creationId xmlns:a16="http://schemas.microsoft.com/office/drawing/2014/main" id="{38902B49-8537-4913-8FBD-CAFBB6D0969D}"/>
+                <a16:creationId xmlns:a16="http://schemas.microsoft.com/office/drawing/2014/main" id="{7833CBAB-AA4F-4936-9DE7-F5FBE613A9C6}"/>
               </a:ext>
             </a:extLst>
           </p:cNvPr>
@@ -2631,7 +2631,7 @@
           <p:cNvPr id="4" name="Title">
             <a:extLst xmlns:a="http://schemas.openxmlformats.org/drawingml/2006/main">
               <a:ext uri="{FF2B5EF4-FFF2-40B4-BE49-F238E27FC236}">
-                <a16:creationId xmlns:a16="http://schemas.microsoft.com/office/drawing/2014/main" id="{A055AC80-5FF3-437E-B360-1C24FAA2DF0E}"/>
+                <a16:creationId xmlns:a16="http://schemas.microsoft.com/office/drawing/2014/main" id="{AAC6CC63-A9C7-466E-AD11-344D1CABDE97}"/>
               </a:ext>
             </a:extLst>
           </p:cNvPr>
@@ -2860,7 +2860,7 @@
           <p:cNvPr id="2" name="Left column">
             <a:extLst xmlns:a="http://schemas.openxmlformats.org/drawingml/2006/main">
               <a:ext uri="{FF2B5EF4-FFF2-40B4-BE49-F238E27FC236}">
-                <a16:creationId xmlns:a16="http://schemas.microsoft.com/office/drawing/2014/main" id="{E434A1FC-E2BA-4209-8983-92F747B886B1}"/>
+                <a16:creationId xmlns:a16="http://schemas.microsoft.com/office/drawing/2014/main" id="{A18CA786-5D40-4C02-944C-2AFF13C314E6}"/>
               </a:ext>
             </a:extLst>
           </p:cNvPr>
@@ -3089,7 +3089,7 @@
           <p:cNvPr id="3" name="Right column">
             <a:extLst xmlns:a="http://schemas.openxmlformats.org/drawingml/2006/main">
               <a:ext uri="{FF2B5EF4-FFF2-40B4-BE49-F238E27FC236}">
-                <a16:creationId xmlns:a16="http://schemas.microsoft.com/office/drawing/2014/main" id="{9D32D43B-6B1D-4F8D-B724-7C7EA3A3CE59}"/>
+                <a16:creationId xmlns:a16="http://schemas.microsoft.com/office/drawing/2014/main" id="{00209DEF-9F0C-45C2-AC48-7EAE8CCE0489}"/>
               </a:ext>
             </a:extLst>
           </p:cNvPr>
@@ -3335,7 +3335,7 @@
           <p:cNvPr id="3" name="Title">
             <a:extLst xmlns:a="http://schemas.openxmlformats.org/drawingml/2006/main">
               <a:ext uri="{FF2B5EF4-FFF2-40B4-BE49-F238E27FC236}">
-                <a16:creationId xmlns:a16="http://schemas.microsoft.com/office/drawing/2014/main" id="{BF037A49-8FE6-453B-A676-ED1F82BE3720}"/>
+                <a16:creationId xmlns:a16="http://schemas.microsoft.com/office/drawing/2014/main" id="{F12CB431-7C3B-45CD-B8C9-47680BD6A572}"/>
               </a:ext>
             </a:extLst>
           </p:cNvPr>
@@ -3564,7 +3564,7 @@
           <p:cNvPr id="2" name="Left column">
             <a:extLst xmlns:a="http://schemas.openxmlformats.org/drawingml/2006/main">
               <a:ext uri="{FF2B5EF4-FFF2-40B4-BE49-F238E27FC236}">
-                <a16:creationId xmlns:a16="http://schemas.microsoft.com/office/drawing/2014/main" id="{B9561161-9633-4025-A176-4BDE730AFECF}"/>
+                <a16:creationId xmlns:a16="http://schemas.microsoft.com/office/drawing/2014/main" id="{D3D80438-0F44-40B0-9856-A679A916B1D6}"/>
               </a:ext>
             </a:extLst>
           </p:cNvPr>
@@ -3831,12 +3831,12 @@
   </p:cSld>
   <p:clrMap bg1="lt1" tx1="dk1" bg2="lt2" tx2="dk2" accent1="accent1" accent2="accent2" accent3="accent3" accent4="accent4" accent5="accent5" accent6="accent6" hlink="hlink" folHlink="folHlink"/>
   <p:sldLayoutIdLst>
-    <p:sldLayoutId xmlns:r="http://schemas.openxmlformats.org/officeDocument/2006/relationships" id="2147483649" r:id="R1ef88810f9c846b8"/>
-    <p:sldLayoutId xmlns:r="http://schemas.openxmlformats.org/officeDocument/2006/relationships" id="2147483650" r:id="R85632f2b19cf49d4"/>
-    <p:sldLayoutId xmlns:r="http://schemas.openxmlformats.org/officeDocument/2006/relationships" id="2147483651" r:id="Re24149b4ff344b4e"/>
-    <p:sldLayoutId xmlns:r="http://schemas.openxmlformats.org/officeDocument/2006/relationships" id="2147483652" r:id="R9ceb3900b0604f22"/>
-    <p:sldLayoutId xmlns:r="http://schemas.openxmlformats.org/officeDocument/2006/relationships" id="2147483653" r:id="R0650c660aa17441c"/>
-    <p:sldLayoutId xmlns:r="http://schemas.openxmlformats.org/officeDocument/2006/relationships" id="2147483654" r:id="Rcbb4707a561f40bf"/>
+    <p:sldLayoutId xmlns:r="http://schemas.openxmlformats.org/officeDocument/2006/relationships" id="2147483649" r:id="Ra69a6bc571a54e4e"/>
+    <p:sldLayoutId xmlns:r="http://schemas.openxmlformats.org/officeDocument/2006/relationships" id="2147483650" r:id="R474b2bf624204773"/>
+    <p:sldLayoutId xmlns:r="http://schemas.openxmlformats.org/officeDocument/2006/relationships" id="2147483651" r:id="R1b0873b272f04724"/>
+    <p:sldLayoutId xmlns:r="http://schemas.openxmlformats.org/officeDocument/2006/relationships" id="2147483652" r:id="R59b80270a33b4921"/>
+    <p:sldLayoutId xmlns:r="http://schemas.openxmlformats.org/officeDocument/2006/relationships" id="2147483653" r:id="R8b0795f756b14c45"/>
+    <p:sldLayoutId xmlns:r="http://schemas.openxmlformats.org/officeDocument/2006/relationships" id="2147483654" r:id="R90abdbb2d70d4e81"/>
   </p:sldLayoutIdLst>
   <p:txStyles>
     <p:titleStyle>
@@ -4387,7 +4387,7 @@
           <p:cNvPr id="6" name="text-1">
             <a:extLst xmlns:a="http://schemas.openxmlformats.org/drawingml/2006/main">
               <a:ext uri="{FF2B5EF4-FFF2-40B4-BE49-F238E27FC236}">
-                <a16:creationId xmlns:a16="http://schemas.microsoft.com/office/drawing/2014/main" id="{3B4DACFE-672A-42D2-9DC0-FE8E51EBB2D1}"/>
+                <a16:creationId xmlns:a16="http://schemas.microsoft.com/office/drawing/2014/main" id="{43DB6A34-0604-4739-B727-3ACA797FC937}"/>
               </a:ext>
             </a:extLst>
           </p:cNvPr>
@@ -4545,7 +4545,7 @@
           <p:cNvPr id="2" name="text-2">
             <a:extLst xmlns:a="http://schemas.openxmlformats.org/drawingml/2006/main">
               <a:ext uri="{FF2B5EF4-FFF2-40B4-BE49-F238E27FC236}">
-                <a16:creationId xmlns:a16="http://schemas.microsoft.com/office/drawing/2014/main" id="{0F0CACA0-3856-4890-A62D-8BF5DD537490}"/>
+                <a16:creationId xmlns:a16="http://schemas.microsoft.com/office/drawing/2014/main" id="{8602413D-12E1-4EF6-8703-635D3632AA71}"/>
               </a:ext>
             </a:extLst>
           </p:cNvPr>
@@ -4703,7 +4703,7 @@
           <p:cNvPr id="3" name="text-3">
             <a:extLst xmlns:a="http://schemas.openxmlformats.org/drawingml/2006/main">
               <a:ext uri="{FF2B5EF4-FFF2-40B4-BE49-F238E27FC236}">
-                <a16:creationId xmlns:a16="http://schemas.microsoft.com/office/drawing/2014/main" id="{A0DDA6B6-129A-4FDB-9D45-DFC619C2F890}"/>
+                <a16:creationId xmlns:a16="http://schemas.microsoft.com/office/drawing/2014/main" id="{9916473E-F004-44E5-ABFB-344572B2526F}"/>
               </a:ext>
             </a:extLst>
           </p:cNvPr>
@@ -4861,7 +4861,7 @@
           <p:cNvPr id="4" name="text-4">
             <a:extLst xmlns:a="http://schemas.openxmlformats.org/drawingml/2006/main">
               <a:ext uri="{FF2B5EF4-FFF2-40B4-BE49-F238E27FC236}">
-                <a16:creationId xmlns:a16="http://schemas.microsoft.com/office/drawing/2014/main" id="{70FD8222-F816-48D5-ACAB-52EBEBA5F94C}"/>
+                <a16:creationId xmlns:a16="http://schemas.microsoft.com/office/drawing/2014/main" id="{1257FF0B-89B0-44E3-9F08-A05A6FE39E9C}"/>
               </a:ext>
             </a:extLst>
           </p:cNvPr>
@@ -5019,7 +5019,7 @@
           <p:cNvPr id="5" name="text-5">
             <a:extLst xmlns:a="http://schemas.openxmlformats.org/drawingml/2006/main">
               <a:ext uri="{FF2B5EF4-FFF2-40B4-BE49-F238E27FC236}">
-                <a16:creationId xmlns:a16="http://schemas.microsoft.com/office/drawing/2014/main" id="{9587D666-CCED-449C-8671-0B0D9F881EDB}"/>
+                <a16:creationId xmlns:a16="http://schemas.microsoft.com/office/drawing/2014/main" id="{AB8C136D-AF4B-4542-B01D-ABB27452B9CA}"/>
               </a:ext>
             </a:extLst>
           </p:cNvPr>
@@ -5175,7 +5175,7 @@
     </p:spTree>
     <p:extLst>
       <p:ext uri="{BB962C8B-B14F-4D97-AF65-F5344CB8AC3E}">
-        <p14:creationId xmlns:p14="http://schemas.microsoft.com/office/powerpoint/2010/main" val="1268226404"/>
+        <p14:creationId xmlns:p14="http://schemas.microsoft.com/office/powerpoint/2010/main" val="785447398"/>
       </p:ext>
     </p:extLst>
   </p:cSld>
@@ -5206,7 +5206,7 @@
           <p:cNvPr id="11" name="text-79">
             <a:extLst xmlns:a="http://schemas.openxmlformats.org/drawingml/2006/main">
               <a:ext uri="{FF2B5EF4-FFF2-40B4-BE49-F238E27FC236}">
-                <a16:creationId xmlns:a16="http://schemas.microsoft.com/office/drawing/2014/main" id="{ABBF00E0-92C4-4F8E-B7C3-D8278FC93D78}"/>
+                <a16:creationId xmlns:a16="http://schemas.microsoft.com/office/drawing/2014/main" id="{5ED91956-53DC-40B2-8C2E-2DCD681F92B2}"/>
               </a:ext>
             </a:extLst>
           </p:cNvPr>
@@ -5364,7 +5364,7 @@
           <p:cNvPr id="2" name="text-80">
             <a:extLst xmlns:a="http://schemas.openxmlformats.org/drawingml/2006/main">
               <a:ext uri="{FF2B5EF4-FFF2-40B4-BE49-F238E27FC236}">
-                <a16:creationId xmlns:a16="http://schemas.microsoft.com/office/drawing/2014/main" id="{8A2EE3A5-351C-42AA-A09E-A541CB73AD3F}"/>
+                <a16:creationId xmlns:a16="http://schemas.microsoft.com/office/drawing/2014/main" id="{3AE54ECB-38A7-4E7B-829E-0AAFF55CAB65}"/>
               </a:ext>
             </a:extLst>
           </p:cNvPr>
@@ -5522,7 +5522,7 @@
           <p:cNvPr id="3" name="text-81">
             <a:extLst xmlns:a="http://schemas.openxmlformats.org/drawingml/2006/main">
               <a:ext uri="{FF2B5EF4-FFF2-40B4-BE49-F238E27FC236}">
-                <a16:creationId xmlns:a16="http://schemas.microsoft.com/office/drawing/2014/main" id="{40A5D161-930C-416B-A12F-25C16623AD84}"/>
+                <a16:creationId xmlns:a16="http://schemas.microsoft.com/office/drawing/2014/main" id="{F8B1B9A0-3EBA-4178-AE53-F8E4E21D2B21}"/>
               </a:ext>
             </a:extLst>
           </p:cNvPr>
@@ -5680,7 +5680,7 @@
           <p:cNvPr id="4" name="text-82">
             <a:extLst xmlns:a="http://schemas.openxmlformats.org/drawingml/2006/main">
               <a:ext uri="{FF2B5EF4-FFF2-40B4-BE49-F238E27FC236}">
-                <a16:creationId xmlns:a16="http://schemas.microsoft.com/office/drawing/2014/main" id="{E1C9CA45-687C-4F2F-B29B-5CDEDBF25BCB}"/>
+                <a16:creationId xmlns:a16="http://schemas.microsoft.com/office/drawing/2014/main" id="{EF928724-C8AD-4C23-9F2A-A3A52BB2D2D5}"/>
               </a:ext>
             </a:extLst>
           </p:cNvPr>
@@ -5838,7 +5838,7 @@
           <p:cNvPr id="5" name="text-83">
             <a:extLst xmlns:a="http://schemas.openxmlformats.org/drawingml/2006/main">
               <a:ext uri="{FF2B5EF4-FFF2-40B4-BE49-F238E27FC236}">
-                <a16:creationId xmlns:a16="http://schemas.microsoft.com/office/drawing/2014/main" id="{BF695AAE-2B82-442F-8DDB-BDF5BCD54664}"/>
+                <a16:creationId xmlns:a16="http://schemas.microsoft.com/office/drawing/2014/main" id="{EFA8FDCB-FDEC-4FFD-A251-A43E03C46A57}"/>
               </a:ext>
             </a:extLst>
           </p:cNvPr>
@@ -6042,7 +6042,7 @@
           <p:cNvPr id="6" name="text-84">
             <a:extLst xmlns:a="http://schemas.openxmlformats.org/drawingml/2006/main">
               <a:ext uri="{FF2B5EF4-FFF2-40B4-BE49-F238E27FC236}">
-                <a16:creationId xmlns:a16="http://schemas.microsoft.com/office/drawing/2014/main" id="{B304DFFC-3A8C-48F7-980F-DCDF80BBE355}"/>
+                <a16:creationId xmlns:a16="http://schemas.microsoft.com/office/drawing/2014/main" id="{12E1E32C-7A8D-450B-AACF-4E8EB42DD98A}"/>
               </a:ext>
             </a:extLst>
           </p:cNvPr>
@@ -6200,7 +6200,7 @@
           <p:cNvPr id="7" name="text-85">
             <a:extLst xmlns:a="http://schemas.openxmlformats.org/drawingml/2006/main">
               <a:ext uri="{FF2B5EF4-FFF2-40B4-BE49-F238E27FC236}">
-                <a16:creationId xmlns:a16="http://schemas.microsoft.com/office/drawing/2014/main" id="{E30B9A2F-9299-4C3B-A677-B6D229D93B4C}"/>
+                <a16:creationId xmlns:a16="http://schemas.microsoft.com/office/drawing/2014/main" id="{BF95C1F2-5964-4045-B27A-B81750FB1E19}"/>
               </a:ext>
             </a:extLst>
           </p:cNvPr>
@@ -6404,7 +6404,7 @@
           <p:cNvPr id="8" name="text-86">
             <a:extLst xmlns:a="http://schemas.openxmlformats.org/drawingml/2006/main">
               <a:ext uri="{FF2B5EF4-FFF2-40B4-BE49-F238E27FC236}">
-                <a16:creationId xmlns:a16="http://schemas.microsoft.com/office/drawing/2014/main" id="{8B0A0B71-9103-4700-B9E1-0D597D879CA6}"/>
+                <a16:creationId xmlns:a16="http://schemas.microsoft.com/office/drawing/2014/main" id="{69F0C187-7AB8-41B3-B893-C72273DFB7E2}"/>
               </a:ext>
             </a:extLst>
           </p:cNvPr>
@@ -6585,7 +6585,7 @@
           <p:cNvPr id="9" name="">
             <a:extLst xmlns:a="http://schemas.openxmlformats.org/drawingml/2006/main">
               <a:ext uri="{FF2B5EF4-FFF2-40B4-BE49-F238E27FC236}">
-                <a16:creationId xmlns:a16="http://schemas.microsoft.com/office/drawing/2014/main" id="{306468C1-1A04-41B1-A9A4-C9DBDA93A8F1}"/>
+                <a16:creationId xmlns:a16="http://schemas.microsoft.com/office/drawing/2014/main" id="{1D9568BF-C6D9-45AE-A86B-6C9BCFEF8FB5}"/>
               </a:ext>
             </a:extLst>
           </p:cNvPr>
@@ -6595,7 +6595,7 @@
           <p:nvPr/>
         </p:nvPicPr>
         <p:blipFill>
-          <a:blip xmlns:r="http://schemas.openxmlformats.org/officeDocument/2006/relationships" xmlns:a="http://schemas.openxmlformats.org/drawingml/2006/main" r:embed="R0eee81822d554998"/>
+          <a:blip xmlns:r="http://schemas.openxmlformats.org/officeDocument/2006/relationships" xmlns:a="http://schemas.openxmlformats.org/drawingml/2006/main" r:embed="R0059778a723e47cc"/>
           <a:srcRect xmlns:a="http://schemas.openxmlformats.org/drawingml/2006/main" l="0" t="0" r="0" b="0"/>
           <a:stretch xmlns:a="http://schemas.openxmlformats.org/drawingml/2006/main"/>
         </p:blipFill>
@@ -6614,7 +6614,7 @@
           <p:cNvPr id="10" name="text-87">
             <a:extLst xmlns:a="http://schemas.openxmlformats.org/drawingml/2006/main">
               <a:ext uri="{FF2B5EF4-FFF2-40B4-BE49-F238E27FC236}">
-                <a16:creationId xmlns:a16="http://schemas.microsoft.com/office/drawing/2014/main" id="{B2007107-EB4B-42A9-9F3C-BB7B8CF8097D}"/>
+                <a16:creationId xmlns:a16="http://schemas.microsoft.com/office/drawing/2014/main" id="{334E4689-7941-4D2F-89C2-677FB2743D1E}"/>
               </a:ext>
             </a:extLst>
           </p:cNvPr>
@@ -6770,7 +6770,7 @@
     </p:spTree>
     <p:extLst>
       <p:ext uri="{BB962C8B-B14F-4D97-AF65-F5344CB8AC3E}">
-        <p14:creationId xmlns:p14="http://schemas.microsoft.com/office/powerpoint/2010/main" val="1283261914"/>
+        <p14:creationId xmlns:p14="http://schemas.microsoft.com/office/powerpoint/2010/main" val="326735901"/>
       </p:ext>
     </p:extLst>
   </p:cSld>
@@ -6801,7 +6801,7 @@
           <p:cNvPr id="10" name="text-88">
             <a:extLst xmlns:a="http://schemas.openxmlformats.org/drawingml/2006/main">
               <a:ext uri="{FF2B5EF4-FFF2-40B4-BE49-F238E27FC236}">
-                <a16:creationId xmlns:a16="http://schemas.microsoft.com/office/drawing/2014/main" id="{A1AABF87-0490-4566-9DC9-EAD26ECCEAB4}"/>
+                <a16:creationId xmlns:a16="http://schemas.microsoft.com/office/drawing/2014/main" id="{014BD2A9-16C6-41DE-A35F-56BC44A3BE52}"/>
               </a:ext>
             </a:extLst>
           </p:cNvPr>
@@ -6959,7 +6959,7 @@
           <p:cNvPr id="2" name="text-89">
             <a:extLst xmlns:a="http://schemas.openxmlformats.org/drawingml/2006/main">
               <a:ext uri="{FF2B5EF4-FFF2-40B4-BE49-F238E27FC236}">
-                <a16:creationId xmlns:a16="http://schemas.microsoft.com/office/drawing/2014/main" id="{638A3FFD-040B-4228-A0D1-92CFA980EA52}"/>
+                <a16:creationId xmlns:a16="http://schemas.microsoft.com/office/drawing/2014/main" id="{9DF23666-A638-4252-980D-DD23B7FE3221}"/>
               </a:ext>
             </a:extLst>
           </p:cNvPr>
@@ -7117,7 +7117,7 @@
           <p:cNvPr id="3" name="text-90">
             <a:extLst xmlns:a="http://schemas.openxmlformats.org/drawingml/2006/main">
               <a:ext uri="{FF2B5EF4-FFF2-40B4-BE49-F238E27FC236}">
-                <a16:creationId xmlns:a16="http://schemas.microsoft.com/office/drawing/2014/main" id="{314186CB-D9F3-452A-B217-4F7613AE3CAB}"/>
+                <a16:creationId xmlns:a16="http://schemas.microsoft.com/office/drawing/2014/main" id="{944E9228-6D96-4CC7-B0BA-7BA652B1BC11}"/>
               </a:ext>
             </a:extLst>
           </p:cNvPr>
@@ -7275,7 +7275,7 @@
           <p:cNvPr id="4" name="text-91">
             <a:extLst xmlns:a="http://schemas.openxmlformats.org/drawingml/2006/main">
               <a:ext uri="{FF2B5EF4-FFF2-40B4-BE49-F238E27FC236}">
-                <a16:creationId xmlns:a16="http://schemas.microsoft.com/office/drawing/2014/main" id="{B63724E2-E303-49FA-8112-8D177A658EA0}"/>
+                <a16:creationId xmlns:a16="http://schemas.microsoft.com/office/drawing/2014/main" id="{DAEB3937-8DD0-4F91-956B-6E45EF0D1ED5}"/>
               </a:ext>
             </a:extLst>
           </p:cNvPr>
@@ -7433,7 +7433,7 @@
           <p:cNvPr id="5" name="text-92">
             <a:extLst xmlns:a="http://schemas.openxmlformats.org/drawingml/2006/main">
               <a:ext uri="{FF2B5EF4-FFF2-40B4-BE49-F238E27FC236}">
-                <a16:creationId xmlns:a16="http://schemas.microsoft.com/office/drawing/2014/main" id="{60E43043-94DD-420B-A101-E3F0F41DF3FB}"/>
+                <a16:creationId xmlns:a16="http://schemas.microsoft.com/office/drawing/2014/main" id="{D1C5A896-9C31-4E67-9130-B3F07DD606B4}"/>
               </a:ext>
             </a:extLst>
           </p:cNvPr>
@@ -7637,7 +7637,7 @@
           <p:cNvPr id="6" name="text-93">
             <a:extLst xmlns:a="http://schemas.openxmlformats.org/drawingml/2006/main">
               <a:ext uri="{FF2B5EF4-FFF2-40B4-BE49-F238E27FC236}">
-                <a16:creationId xmlns:a16="http://schemas.microsoft.com/office/drawing/2014/main" id="{BDE1B361-3DEB-4C1F-90BE-872C74058423}"/>
+                <a16:creationId xmlns:a16="http://schemas.microsoft.com/office/drawing/2014/main" id="{B66F4568-6AC6-4967-9BD5-B7E5B580CB19}"/>
               </a:ext>
             </a:extLst>
           </p:cNvPr>
@@ -7795,7 +7795,7 @@
           <p:cNvPr id="7" name="text-94">
             <a:extLst xmlns:a="http://schemas.openxmlformats.org/drawingml/2006/main">
               <a:ext uri="{FF2B5EF4-FFF2-40B4-BE49-F238E27FC236}">
-                <a16:creationId xmlns:a16="http://schemas.microsoft.com/office/drawing/2014/main" id="{C9DF57F4-EA15-4BE3-B20B-7F895F85249E}"/>
+                <a16:creationId xmlns:a16="http://schemas.microsoft.com/office/drawing/2014/main" id="{DF2A1B77-CBF6-464D-A7BF-EF17120A736F}"/>
               </a:ext>
             </a:extLst>
           </p:cNvPr>
@@ -7999,7 +7999,7 @@
           <p:cNvPr id="8" name="text-95">
             <a:extLst xmlns:a="http://schemas.openxmlformats.org/drawingml/2006/main">
               <a:ext uri="{FF2B5EF4-FFF2-40B4-BE49-F238E27FC236}">
-                <a16:creationId xmlns:a16="http://schemas.microsoft.com/office/drawing/2014/main" id="{64086469-61AC-4E69-A9AD-114B351A90A3}"/>
+                <a16:creationId xmlns:a16="http://schemas.microsoft.com/office/drawing/2014/main" id="{E695D913-CE40-4EAB-8EDA-D24811722770}"/>
               </a:ext>
             </a:extLst>
           </p:cNvPr>
@@ -8203,7 +8203,7 @@
           <p:cNvPr id="9" name="">
             <a:extLst xmlns:a="http://schemas.openxmlformats.org/drawingml/2006/main">
               <a:ext uri="{FF2B5EF4-FFF2-40B4-BE49-F238E27FC236}">
-                <a16:creationId xmlns:a16="http://schemas.microsoft.com/office/drawing/2014/main" id="{8E724E14-904B-4353-8A23-5F82DCFD1D50}"/>
+                <a16:creationId xmlns:a16="http://schemas.microsoft.com/office/drawing/2014/main" id="{D5586EBE-FC54-4F13-9DC2-6079278E1295}"/>
               </a:ext>
             </a:extLst>
           </p:cNvPr>
@@ -8213,7 +8213,7 @@
           <p:nvPr/>
         </p:nvPicPr>
         <p:blipFill>
-          <a:blip xmlns:r="http://schemas.openxmlformats.org/officeDocument/2006/relationships" xmlns:a="http://schemas.openxmlformats.org/drawingml/2006/main" r:embed="R9294b8fa091f444b"/>
+          <a:blip xmlns:r="http://schemas.openxmlformats.org/officeDocument/2006/relationships" xmlns:a="http://schemas.openxmlformats.org/drawingml/2006/main" r:embed="R06d3ee062bd24610"/>
           <a:srcRect xmlns:a="http://schemas.openxmlformats.org/drawingml/2006/main" l="0" t="0" r="0" b="0"/>
           <a:stretch xmlns:a="http://schemas.openxmlformats.org/drawingml/2006/main"/>
         </p:blipFill>
@@ -8230,7 +8230,7 @@
     </p:spTree>
     <p:extLst>
       <p:ext uri="{BB962C8B-B14F-4D97-AF65-F5344CB8AC3E}">
-        <p14:creationId xmlns:p14="http://schemas.microsoft.com/office/powerpoint/2010/main" val="193757672"/>
+        <p14:creationId xmlns:p14="http://schemas.microsoft.com/office/powerpoint/2010/main" val="721506718"/>
       </p:ext>
     </p:extLst>
   </p:cSld>
@@ -8261,7 +8261,7 @@
           <p:cNvPr id="12" name="text-96">
             <a:extLst xmlns:a="http://schemas.openxmlformats.org/drawingml/2006/main">
               <a:ext uri="{FF2B5EF4-FFF2-40B4-BE49-F238E27FC236}">
-                <a16:creationId xmlns:a16="http://schemas.microsoft.com/office/drawing/2014/main" id="{DA1E3972-1FB5-4A23-B10D-468A0222F317}"/>
+                <a16:creationId xmlns:a16="http://schemas.microsoft.com/office/drawing/2014/main" id="{5EE966F8-418D-481B-96DD-41C3B6DD4525}"/>
               </a:ext>
             </a:extLst>
           </p:cNvPr>
@@ -8419,7 +8419,7 @@
           <p:cNvPr id="2" name="text-97">
             <a:extLst xmlns:a="http://schemas.openxmlformats.org/drawingml/2006/main">
               <a:ext uri="{FF2B5EF4-FFF2-40B4-BE49-F238E27FC236}">
-                <a16:creationId xmlns:a16="http://schemas.microsoft.com/office/drawing/2014/main" id="{70FD09CD-C183-4620-A616-488431B50B40}"/>
+                <a16:creationId xmlns:a16="http://schemas.microsoft.com/office/drawing/2014/main" id="{B707C669-54F0-49BD-BDB3-49446DD34646}"/>
               </a:ext>
             </a:extLst>
           </p:cNvPr>
@@ -8577,7 +8577,7 @@
           <p:cNvPr id="3" name="text-98">
             <a:extLst xmlns:a="http://schemas.openxmlformats.org/drawingml/2006/main">
               <a:ext uri="{FF2B5EF4-FFF2-40B4-BE49-F238E27FC236}">
-                <a16:creationId xmlns:a16="http://schemas.microsoft.com/office/drawing/2014/main" id="{3B4217CE-D272-4ACB-9CCA-E9476EBF8B0C}"/>
+                <a16:creationId xmlns:a16="http://schemas.microsoft.com/office/drawing/2014/main" id="{801C7320-DF80-4F4A-9223-854BEFC90BB2}"/>
               </a:ext>
             </a:extLst>
           </p:cNvPr>
@@ -8735,7 +8735,7 @@
           <p:cNvPr id="4" name="text-99">
             <a:extLst xmlns:a="http://schemas.openxmlformats.org/drawingml/2006/main">
               <a:ext uri="{FF2B5EF4-FFF2-40B4-BE49-F238E27FC236}">
-                <a16:creationId xmlns:a16="http://schemas.microsoft.com/office/drawing/2014/main" id="{61BE2223-DD91-4615-866F-447CB7C65C97}"/>
+                <a16:creationId xmlns:a16="http://schemas.microsoft.com/office/drawing/2014/main" id="{A350AA29-F5A9-472D-80E0-F27BB986A808}"/>
               </a:ext>
             </a:extLst>
           </p:cNvPr>
@@ -8893,7 +8893,7 @@
           <p:cNvPr id="5" name="text-100">
             <a:extLst xmlns:a="http://schemas.openxmlformats.org/drawingml/2006/main">
               <a:ext uri="{FF2B5EF4-FFF2-40B4-BE49-F238E27FC236}">
-                <a16:creationId xmlns:a16="http://schemas.microsoft.com/office/drawing/2014/main" id="{A2B8DC73-F167-4C4D-A253-ED6DE1893D12}"/>
+                <a16:creationId xmlns:a16="http://schemas.microsoft.com/office/drawing/2014/main" id="{29CF89CB-CB3E-4B8E-8483-6C7BBB4C3397}"/>
               </a:ext>
             </a:extLst>
           </p:cNvPr>
@@ -9097,7 +9097,7 @@
           <p:cNvPr id="6" name="text-101">
             <a:extLst xmlns:a="http://schemas.openxmlformats.org/drawingml/2006/main">
               <a:ext uri="{FF2B5EF4-FFF2-40B4-BE49-F238E27FC236}">
-                <a16:creationId xmlns:a16="http://schemas.microsoft.com/office/drawing/2014/main" id="{50511506-1A74-4006-A4AE-18EBE765F99B}"/>
+                <a16:creationId xmlns:a16="http://schemas.microsoft.com/office/drawing/2014/main" id="{673E5832-98B2-4874-BA99-711E1B467C0A}"/>
               </a:ext>
             </a:extLst>
           </p:cNvPr>
@@ -9255,7 +9255,7 @@
           <p:cNvPr id="7" name="text-102">
             <a:extLst xmlns:a="http://schemas.openxmlformats.org/drawingml/2006/main">
               <a:ext uri="{FF2B5EF4-FFF2-40B4-BE49-F238E27FC236}">
-                <a16:creationId xmlns:a16="http://schemas.microsoft.com/office/drawing/2014/main" id="{92293486-F03F-440A-A9F1-7AB1BF18F9F1}"/>
+                <a16:creationId xmlns:a16="http://schemas.microsoft.com/office/drawing/2014/main" id="{E0669BEB-05BA-4924-A473-97475CC2A3FB}"/>
               </a:ext>
             </a:extLst>
           </p:cNvPr>
@@ -9459,7 +9459,7 @@
           <p:cNvPr id="8" name="text-103">
             <a:extLst xmlns:a="http://schemas.openxmlformats.org/drawingml/2006/main">
               <a:ext uri="{FF2B5EF4-FFF2-40B4-BE49-F238E27FC236}">
-                <a16:creationId xmlns:a16="http://schemas.microsoft.com/office/drawing/2014/main" id="{B875BFBE-BAD1-48D9-AFF9-424E6DC6E8A6}"/>
+                <a16:creationId xmlns:a16="http://schemas.microsoft.com/office/drawing/2014/main" id="{4D4598C4-2F61-43E9-AC3B-0F5B41AE7665}"/>
               </a:ext>
             </a:extLst>
           </p:cNvPr>
@@ -9663,7 +9663,7 @@
           <p:cNvPr id="9" name="">
             <a:extLst xmlns:a="http://schemas.openxmlformats.org/drawingml/2006/main">
               <a:ext uri="{FF2B5EF4-FFF2-40B4-BE49-F238E27FC236}">
-                <a16:creationId xmlns:a16="http://schemas.microsoft.com/office/drawing/2014/main" id="{5FDDCE3D-B800-4E56-93BC-005DA1E89F78}"/>
+                <a16:creationId xmlns:a16="http://schemas.microsoft.com/office/drawing/2014/main" id="{86FB2138-ADDA-454F-A91C-51B7C0467094}"/>
               </a:ext>
             </a:extLst>
           </p:cNvPr>
@@ -9673,7 +9673,7 @@
           <p:nvPr/>
         </p:nvPicPr>
         <p:blipFill>
-          <a:blip xmlns:r="http://schemas.openxmlformats.org/officeDocument/2006/relationships" xmlns:a="http://schemas.openxmlformats.org/drawingml/2006/main" r:embed="R33a26f09661a4e72"/>
+          <a:blip xmlns:r="http://schemas.openxmlformats.org/officeDocument/2006/relationships" xmlns:a="http://schemas.openxmlformats.org/drawingml/2006/main" r:embed="R3b632717507a4a02"/>
           <a:srcRect xmlns:a="http://schemas.openxmlformats.org/drawingml/2006/main" l="0" t="80240" r="0" b="0"/>
           <a:stretch xmlns:a="http://schemas.openxmlformats.org/drawingml/2006/main"/>
         </p:blipFill>
@@ -9692,7 +9692,7 @@
           <p:cNvPr id="10" name="text-104">
             <a:extLst xmlns:a="http://schemas.openxmlformats.org/drawingml/2006/main">
               <a:ext uri="{FF2B5EF4-FFF2-40B4-BE49-F238E27FC236}">
-                <a16:creationId xmlns:a16="http://schemas.microsoft.com/office/drawing/2014/main" id="{1C05AD5E-5B3E-45F4-9AC9-43B5DB746CEE}"/>
+                <a16:creationId xmlns:a16="http://schemas.microsoft.com/office/drawing/2014/main" id="{1FF23882-F65F-4069-8DC2-4F4BCA36B5F8}"/>
               </a:ext>
             </a:extLst>
           </p:cNvPr>
@@ -9850,7 +9850,7 @@
           <p:cNvPr id="11" name="text-105">
             <a:extLst xmlns:a="http://schemas.openxmlformats.org/drawingml/2006/main">
               <a:ext uri="{FF2B5EF4-FFF2-40B4-BE49-F238E27FC236}">
-                <a16:creationId xmlns:a16="http://schemas.microsoft.com/office/drawing/2014/main" id="{B0429C2C-681A-45C0-A81C-72CFBA2A64ED}"/>
+                <a16:creationId xmlns:a16="http://schemas.microsoft.com/office/drawing/2014/main" id="{D9E05DD2-5212-45F6-8376-3F612214D45E}"/>
               </a:ext>
             </a:extLst>
           </p:cNvPr>
@@ -10006,7 +10006,7 @@
     </p:spTree>
     <p:extLst>
       <p:ext uri="{BB962C8B-B14F-4D97-AF65-F5344CB8AC3E}">
-        <p14:creationId xmlns:p14="http://schemas.microsoft.com/office/powerpoint/2010/main" val="1186299137"/>
+        <p14:creationId xmlns:p14="http://schemas.microsoft.com/office/powerpoint/2010/main" val="477725511"/>
       </p:ext>
     </p:extLst>
   </p:cSld>
@@ -10037,7 +10037,7 @@
           <p:cNvPr id="12" name="text-6">
             <a:extLst xmlns:a="http://schemas.openxmlformats.org/drawingml/2006/main">
               <a:ext uri="{FF2B5EF4-FFF2-40B4-BE49-F238E27FC236}">
-                <a16:creationId xmlns:a16="http://schemas.microsoft.com/office/drawing/2014/main" id="{21D5D307-075F-4466-805E-2DB291A79CC0}"/>
+                <a16:creationId xmlns:a16="http://schemas.microsoft.com/office/drawing/2014/main" id="{F72304AC-4C54-4B07-9D88-0A718AE59B22}"/>
               </a:ext>
             </a:extLst>
           </p:cNvPr>
@@ -10195,7 +10195,7 @@
           <p:cNvPr id="2" name="text-7">
             <a:extLst xmlns:a="http://schemas.openxmlformats.org/drawingml/2006/main">
               <a:ext uri="{FF2B5EF4-FFF2-40B4-BE49-F238E27FC236}">
-                <a16:creationId xmlns:a16="http://schemas.microsoft.com/office/drawing/2014/main" id="{29BB4250-15FF-4DE9-BF09-D863EB8FA7B8}"/>
+                <a16:creationId xmlns:a16="http://schemas.microsoft.com/office/drawing/2014/main" id="{07D3F384-D205-4841-B389-CBC8ACD2376A}"/>
               </a:ext>
             </a:extLst>
           </p:cNvPr>
@@ -10353,7 +10353,7 @@
           <p:cNvPr id="3" name="text-8">
             <a:extLst xmlns:a="http://schemas.openxmlformats.org/drawingml/2006/main">
               <a:ext uri="{FF2B5EF4-FFF2-40B4-BE49-F238E27FC236}">
-                <a16:creationId xmlns:a16="http://schemas.microsoft.com/office/drawing/2014/main" id="{A1B35834-1D57-4B41-AAF6-4EC4F0AFD36B}"/>
+                <a16:creationId xmlns:a16="http://schemas.microsoft.com/office/drawing/2014/main" id="{926C3BA3-A9CE-4D4C-A135-7E098A95A67D}"/>
               </a:ext>
             </a:extLst>
           </p:cNvPr>
@@ -10511,7 +10511,7 @@
           <p:cNvPr id="4" name="text-9">
             <a:extLst xmlns:a="http://schemas.openxmlformats.org/drawingml/2006/main">
               <a:ext uri="{FF2B5EF4-FFF2-40B4-BE49-F238E27FC236}">
-                <a16:creationId xmlns:a16="http://schemas.microsoft.com/office/drawing/2014/main" id="{B8FFF62F-881B-4BB7-A03E-1C86C869E15B}"/>
+                <a16:creationId xmlns:a16="http://schemas.microsoft.com/office/drawing/2014/main" id="{6BB206AA-B13C-4A71-A27A-93B5429423F4}"/>
               </a:ext>
             </a:extLst>
           </p:cNvPr>
@@ -10669,7 +10669,7 @@
           <p:cNvPr id="5" name="text-10">
             <a:extLst xmlns:a="http://schemas.openxmlformats.org/drawingml/2006/main">
               <a:ext uri="{FF2B5EF4-FFF2-40B4-BE49-F238E27FC236}">
-                <a16:creationId xmlns:a16="http://schemas.microsoft.com/office/drawing/2014/main" id="{FF91544B-7FCB-45DA-AD6D-D931DA3601E4}"/>
+                <a16:creationId xmlns:a16="http://schemas.microsoft.com/office/drawing/2014/main" id="{A179C03C-4DB2-4D77-9F93-BC2BB4D36BF1}"/>
               </a:ext>
             </a:extLst>
           </p:cNvPr>
@@ -10873,7 +10873,7 @@
           <p:cNvPr id="6" name="text-11">
             <a:extLst xmlns:a="http://schemas.openxmlformats.org/drawingml/2006/main">
               <a:ext uri="{FF2B5EF4-FFF2-40B4-BE49-F238E27FC236}">
-                <a16:creationId xmlns:a16="http://schemas.microsoft.com/office/drawing/2014/main" id="{0A4270B0-7426-4BF4-90C0-938BFB33DB17}"/>
+                <a16:creationId xmlns:a16="http://schemas.microsoft.com/office/drawing/2014/main" id="{FC3D2EBB-2C5E-439E-AE76-DBB961819002}"/>
               </a:ext>
             </a:extLst>
           </p:cNvPr>
@@ -11031,7 +11031,7 @@
           <p:cNvPr id="7" name="text-12">
             <a:extLst xmlns:a="http://schemas.openxmlformats.org/drawingml/2006/main">
               <a:ext uri="{FF2B5EF4-FFF2-40B4-BE49-F238E27FC236}">
-                <a16:creationId xmlns:a16="http://schemas.microsoft.com/office/drawing/2014/main" id="{924AE09C-A379-4358-A4C9-745AB8481F2A}"/>
+                <a16:creationId xmlns:a16="http://schemas.microsoft.com/office/drawing/2014/main" id="{390864CC-E9DE-4D29-8EC3-042864583A5F}"/>
               </a:ext>
             </a:extLst>
           </p:cNvPr>
@@ -11212,7 +11212,7 @@
           <p:cNvPr id="8" name="text-13">
             <a:extLst xmlns:a="http://schemas.openxmlformats.org/drawingml/2006/main">
               <a:ext uri="{FF2B5EF4-FFF2-40B4-BE49-F238E27FC236}">
-                <a16:creationId xmlns:a16="http://schemas.microsoft.com/office/drawing/2014/main" id="{E727234B-56F8-4381-8121-45BBE8A40CD4}"/>
+                <a16:creationId xmlns:a16="http://schemas.microsoft.com/office/drawing/2014/main" id="{BAB5F4F6-2316-4913-B4FB-D2A87FAF4BDB}"/>
               </a:ext>
             </a:extLst>
           </p:cNvPr>
@@ -11370,7 +11370,7 @@
           <p:cNvPr id="9" name="text-14">
             <a:extLst xmlns:a="http://schemas.openxmlformats.org/drawingml/2006/main">
               <a:ext uri="{FF2B5EF4-FFF2-40B4-BE49-F238E27FC236}">
-                <a16:creationId xmlns:a16="http://schemas.microsoft.com/office/drawing/2014/main" id="{6E7ECD7C-2CAC-4CC6-8DE0-040919139335}"/>
+                <a16:creationId xmlns:a16="http://schemas.microsoft.com/office/drawing/2014/main" id="{CBFE80A3-336E-4F25-8456-F8F9903525A0}"/>
               </a:ext>
             </a:extLst>
           </p:cNvPr>
@@ -11551,7 +11551,7 @@
           <p:cNvPr id="10" name="">
             <a:extLst xmlns:a="http://schemas.openxmlformats.org/drawingml/2006/main">
               <a:ext uri="{FF2B5EF4-FFF2-40B4-BE49-F238E27FC236}">
-                <a16:creationId xmlns:a16="http://schemas.microsoft.com/office/drawing/2014/main" id="{0F9C245B-D4B2-40F9-99B8-78B742958E80}"/>
+                <a16:creationId xmlns:a16="http://schemas.microsoft.com/office/drawing/2014/main" id="{EDD5C9DF-9A97-4EAC-9AE5-EAA0B0864EEA}"/>
               </a:ext>
             </a:extLst>
           </p:cNvPr>
@@ -11561,7 +11561,7 @@
           <p:nvPr/>
         </p:nvPicPr>
         <p:blipFill>
-          <a:blip xmlns:r="http://schemas.openxmlformats.org/officeDocument/2006/relationships" xmlns:a="http://schemas.openxmlformats.org/drawingml/2006/main" r:embed="R12fa9c7cf2364b60"/>
+          <a:blip xmlns:r="http://schemas.openxmlformats.org/officeDocument/2006/relationships" xmlns:a="http://schemas.openxmlformats.org/drawingml/2006/main" r:embed="R62e8f81026ee45d7"/>
           <a:srcRect xmlns:a="http://schemas.openxmlformats.org/drawingml/2006/main" l="0" t="0" r="0" b="0"/>
           <a:stretch xmlns:a="http://schemas.openxmlformats.org/drawingml/2006/main"/>
         </p:blipFill>
@@ -11580,7 +11580,7 @@
           <p:cNvPr id="11" name="text-15">
             <a:extLst xmlns:a="http://schemas.openxmlformats.org/drawingml/2006/main">
               <a:ext uri="{FF2B5EF4-FFF2-40B4-BE49-F238E27FC236}">
-                <a16:creationId xmlns:a16="http://schemas.microsoft.com/office/drawing/2014/main" id="{C009085F-3CBF-4547-8C2E-690A1EB77DDD}"/>
+                <a16:creationId xmlns:a16="http://schemas.microsoft.com/office/drawing/2014/main" id="{1023768A-4FB7-42EE-825F-2658E7A4AC2F}"/>
               </a:ext>
             </a:extLst>
           </p:cNvPr>
@@ -11736,7 +11736,7 @@
     </p:spTree>
     <p:extLst>
       <p:ext uri="{BB962C8B-B14F-4D97-AF65-F5344CB8AC3E}">
-        <p14:creationId xmlns:p14="http://schemas.microsoft.com/office/powerpoint/2010/main" val="1625572706"/>
+        <p14:creationId xmlns:p14="http://schemas.microsoft.com/office/powerpoint/2010/main" val="1310144534"/>
       </p:ext>
     </p:extLst>
   </p:cSld>
@@ -11767,7 +11767,7 @@
           <p:cNvPr id="11" name="text-16">
             <a:extLst xmlns:a="http://schemas.openxmlformats.org/drawingml/2006/main">
               <a:ext uri="{FF2B5EF4-FFF2-40B4-BE49-F238E27FC236}">
-                <a16:creationId xmlns:a16="http://schemas.microsoft.com/office/drawing/2014/main" id="{49B30DF3-30B5-4A40-83ED-4100C1A99E76}"/>
+                <a16:creationId xmlns:a16="http://schemas.microsoft.com/office/drawing/2014/main" id="{9A05911E-8125-40E8-824F-7F1048C74590}"/>
               </a:ext>
             </a:extLst>
           </p:cNvPr>
@@ -11925,7 +11925,7 @@
           <p:cNvPr id="2" name="text-17">
             <a:extLst xmlns:a="http://schemas.openxmlformats.org/drawingml/2006/main">
               <a:ext uri="{FF2B5EF4-FFF2-40B4-BE49-F238E27FC236}">
-                <a16:creationId xmlns:a16="http://schemas.microsoft.com/office/drawing/2014/main" id="{9D0B80E7-11BF-4394-8694-51A1F06A3A9D}"/>
+                <a16:creationId xmlns:a16="http://schemas.microsoft.com/office/drawing/2014/main" id="{E9255C1D-AB41-405E-8467-B2910D7BAE0A}"/>
               </a:ext>
             </a:extLst>
           </p:cNvPr>
@@ -12083,7 +12083,7 @@
           <p:cNvPr id="3" name="text-18">
             <a:extLst xmlns:a="http://schemas.openxmlformats.org/drawingml/2006/main">
               <a:ext uri="{FF2B5EF4-FFF2-40B4-BE49-F238E27FC236}">
-                <a16:creationId xmlns:a16="http://schemas.microsoft.com/office/drawing/2014/main" id="{6CE10BB4-52DE-4588-A2C2-F7DFA11228A7}"/>
+                <a16:creationId xmlns:a16="http://schemas.microsoft.com/office/drawing/2014/main" id="{9CDEABE0-522D-4B25-821C-7F7645CB489A}"/>
               </a:ext>
             </a:extLst>
           </p:cNvPr>
@@ -12241,7 +12241,7 @@
           <p:cNvPr id="4" name="text-19">
             <a:extLst xmlns:a="http://schemas.openxmlformats.org/drawingml/2006/main">
               <a:ext uri="{FF2B5EF4-FFF2-40B4-BE49-F238E27FC236}">
-                <a16:creationId xmlns:a16="http://schemas.microsoft.com/office/drawing/2014/main" id="{05F3DE8F-EA63-4A74-9FE7-43FFB79BBBB3}"/>
+                <a16:creationId xmlns:a16="http://schemas.microsoft.com/office/drawing/2014/main" id="{AA52B3D8-91D9-436E-96CC-26C47D010104}"/>
               </a:ext>
             </a:extLst>
           </p:cNvPr>
@@ -12399,7 +12399,7 @@
           <p:cNvPr id="5" name="text-20">
             <a:extLst xmlns:a="http://schemas.openxmlformats.org/drawingml/2006/main">
               <a:ext uri="{FF2B5EF4-FFF2-40B4-BE49-F238E27FC236}">
-                <a16:creationId xmlns:a16="http://schemas.microsoft.com/office/drawing/2014/main" id="{214DEAA8-4217-4CB0-9BE6-9D2EE28B4DD4}"/>
+                <a16:creationId xmlns:a16="http://schemas.microsoft.com/office/drawing/2014/main" id="{6B2BA6B5-C145-4A5B-8A6D-F0C10E785FCF}"/>
               </a:ext>
             </a:extLst>
           </p:cNvPr>
@@ -12557,7 +12557,7 @@
           <p:cNvPr id="6" name="text-21">
             <a:extLst xmlns:a="http://schemas.openxmlformats.org/drawingml/2006/main">
               <a:ext uri="{FF2B5EF4-FFF2-40B4-BE49-F238E27FC236}">
-                <a16:creationId xmlns:a16="http://schemas.microsoft.com/office/drawing/2014/main" id="{1460573D-1F55-4E44-A22F-D64DB497510F}"/>
+                <a16:creationId xmlns:a16="http://schemas.microsoft.com/office/drawing/2014/main" id="{D15F076C-F907-47B0-B65B-AB8B91DD0EFD}"/>
               </a:ext>
             </a:extLst>
           </p:cNvPr>
@@ -12715,7 +12715,7 @@
           <p:cNvPr id="7" name="">
             <a:extLst xmlns:a="http://schemas.openxmlformats.org/drawingml/2006/main">
               <a:ext uri="{FF2B5EF4-FFF2-40B4-BE49-F238E27FC236}">
-                <a16:creationId xmlns:a16="http://schemas.microsoft.com/office/drawing/2014/main" id="{CEACEDED-65D5-4E42-83CF-0A4AC20519D6}"/>
+                <a16:creationId xmlns:a16="http://schemas.microsoft.com/office/drawing/2014/main" id="{4FB4624F-DEA5-4236-B950-6FB00452C3EA}"/>
               </a:ext>
             </a:extLst>
           </p:cNvPr>
@@ -12725,7 +12725,7 @@
           <p:nvPr/>
         </p:nvPicPr>
         <p:blipFill>
-          <a:blip xmlns:r="http://schemas.openxmlformats.org/officeDocument/2006/relationships" xmlns:a="http://schemas.openxmlformats.org/drawingml/2006/main" r:embed="R48a8e4004c304007"/>
+          <a:blip xmlns:r="http://schemas.openxmlformats.org/officeDocument/2006/relationships" xmlns:a="http://schemas.openxmlformats.org/drawingml/2006/main" r:embed="Rd9eaae469b7141d3"/>
           <a:srcRect xmlns:a="http://schemas.openxmlformats.org/drawingml/2006/main" l="6875" t="31737" r="72500" b="41916"/>
           <a:stretch xmlns:a="http://schemas.openxmlformats.org/drawingml/2006/main"/>
         </p:blipFill>
@@ -12744,7 +12744,7 @@
           <p:cNvPr id="8" name="">
             <a:extLst xmlns:a="http://schemas.openxmlformats.org/drawingml/2006/main">
               <a:ext uri="{FF2B5EF4-FFF2-40B4-BE49-F238E27FC236}">
-                <a16:creationId xmlns:a16="http://schemas.microsoft.com/office/drawing/2014/main" id="{9A88C757-017E-4E82-8CCB-CEC8177F2357}"/>
+                <a16:creationId xmlns:a16="http://schemas.microsoft.com/office/drawing/2014/main" id="{3157B1B9-89F0-40EA-8C57-F38965ED02B2}"/>
               </a:ext>
             </a:extLst>
           </p:cNvPr>
@@ -12754,7 +12754,7 @@
           <p:nvPr/>
         </p:nvPicPr>
         <p:blipFill>
-          <a:blip xmlns:r="http://schemas.openxmlformats.org/officeDocument/2006/relationships" xmlns:a="http://schemas.openxmlformats.org/drawingml/2006/main" r:embed="Re5eb52f5c95b4cae"/>
+          <a:blip xmlns:r="http://schemas.openxmlformats.org/officeDocument/2006/relationships" xmlns:a="http://schemas.openxmlformats.org/drawingml/2006/main" r:embed="R44943854062f4c2c"/>
           <a:srcRect xmlns:a="http://schemas.openxmlformats.org/drawingml/2006/main" l="68125" t="38323" r="13125" b="28743"/>
           <a:stretch xmlns:a="http://schemas.openxmlformats.org/drawingml/2006/main"/>
         </p:blipFill>
@@ -12773,7 +12773,7 @@
           <p:cNvPr id="9" name="text-22">
             <a:extLst xmlns:a="http://schemas.openxmlformats.org/drawingml/2006/main">
               <a:ext uri="{FF2B5EF4-FFF2-40B4-BE49-F238E27FC236}">
-                <a16:creationId xmlns:a16="http://schemas.microsoft.com/office/drawing/2014/main" id="{0B320C1A-2145-4B03-B649-EEB482D8B75C}"/>
+                <a16:creationId xmlns:a16="http://schemas.microsoft.com/office/drawing/2014/main" id="{E31C6210-D56C-446E-A6FC-39578F4577C7}"/>
               </a:ext>
             </a:extLst>
           </p:cNvPr>
@@ -12954,7 +12954,7 @@
           <p:cNvPr id="10" name="text-23">
             <a:extLst xmlns:a="http://schemas.openxmlformats.org/drawingml/2006/main">
               <a:ext uri="{FF2B5EF4-FFF2-40B4-BE49-F238E27FC236}">
-                <a16:creationId xmlns:a16="http://schemas.microsoft.com/office/drawing/2014/main" id="{8BF47240-2BC1-4523-BE2C-69215C0C0DB3}"/>
+                <a16:creationId xmlns:a16="http://schemas.microsoft.com/office/drawing/2014/main" id="{4B0E0640-ADF0-4237-B62D-3205C7DD82AA}"/>
               </a:ext>
             </a:extLst>
           </p:cNvPr>
@@ -13110,7 +13110,7 @@
     </p:spTree>
     <p:extLst>
       <p:ext uri="{BB962C8B-B14F-4D97-AF65-F5344CB8AC3E}">
-        <p14:creationId xmlns:p14="http://schemas.microsoft.com/office/powerpoint/2010/main" val="978032161"/>
+        <p14:creationId xmlns:p14="http://schemas.microsoft.com/office/powerpoint/2010/main" val="117909199"/>
       </p:ext>
     </p:extLst>
   </p:cSld>
@@ -13141,7 +13141,7 @@
           <p:cNvPr id="11" name="text-24">
             <a:extLst xmlns:a="http://schemas.openxmlformats.org/drawingml/2006/main">
               <a:ext uri="{FF2B5EF4-FFF2-40B4-BE49-F238E27FC236}">
-                <a16:creationId xmlns:a16="http://schemas.microsoft.com/office/drawing/2014/main" id="{55458904-501D-409C-A2A5-3F581D6AA541}"/>
+                <a16:creationId xmlns:a16="http://schemas.microsoft.com/office/drawing/2014/main" id="{C3C6D0BC-C6F1-4E78-AA25-7EFB64E10BBB}"/>
               </a:ext>
             </a:extLst>
           </p:cNvPr>
@@ -13299,7 +13299,7 @@
           <p:cNvPr id="2" name="text-25">
             <a:extLst xmlns:a="http://schemas.openxmlformats.org/drawingml/2006/main">
               <a:ext uri="{FF2B5EF4-FFF2-40B4-BE49-F238E27FC236}">
-                <a16:creationId xmlns:a16="http://schemas.microsoft.com/office/drawing/2014/main" id="{39B3C423-3600-4AA1-8121-C9502B767C74}"/>
+                <a16:creationId xmlns:a16="http://schemas.microsoft.com/office/drawing/2014/main" id="{A9D2BA24-DE4B-4F02-9877-4375F563C07F}"/>
               </a:ext>
             </a:extLst>
           </p:cNvPr>
@@ -13457,7 +13457,7 @@
           <p:cNvPr id="3" name="text-26">
             <a:extLst xmlns:a="http://schemas.openxmlformats.org/drawingml/2006/main">
               <a:ext uri="{FF2B5EF4-FFF2-40B4-BE49-F238E27FC236}">
-                <a16:creationId xmlns:a16="http://schemas.microsoft.com/office/drawing/2014/main" id="{A98A4E61-5075-4800-A65F-C1AE441CFDDC}"/>
+                <a16:creationId xmlns:a16="http://schemas.microsoft.com/office/drawing/2014/main" id="{9C6D1071-6788-4478-A342-FECD8E764BB3}"/>
               </a:ext>
             </a:extLst>
           </p:cNvPr>
@@ -13615,7 +13615,7 @@
           <p:cNvPr id="4" name="text-27">
             <a:extLst xmlns:a="http://schemas.openxmlformats.org/drawingml/2006/main">
               <a:ext uri="{FF2B5EF4-FFF2-40B4-BE49-F238E27FC236}">
-                <a16:creationId xmlns:a16="http://schemas.microsoft.com/office/drawing/2014/main" id="{81D4D548-D46B-4878-ADBA-74E29B18D56D}"/>
+                <a16:creationId xmlns:a16="http://schemas.microsoft.com/office/drawing/2014/main" id="{0DC5683D-E0E8-48B5-A31D-FE322EBEB106}"/>
               </a:ext>
             </a:extLst>
           </p:cNvPr>
@@ -13773,7 +13773,7 @@
           <p:cNvPr id="5" name="text-28">
             <a:extLst xmlns:a="http://schemas.openxmlformats.org/drawingml/2006/main">
               <a:ext uri="{FF2B5EF4-FFF2-40B4-BE49-F238E27FC236}">
-                <a16:creationId xmlns:a16="http://schemas.microsoft.com/office/drawing/2014/main" id="{89EB85C2-0D00-47F9-9A8E-A52CB7FD1E32}"/>
+                <a16:creationId xmlns:a16="http://schemas.microsoft.com/office/drawing/2014/main" id="{6836E4F4-5946-4E55-884E-EBD16E54CAB5}"/>
               </a:ext>
             </a:extLst>
           </p:cNvPr>
@@ -13977,7 +13977,7 @@
           <p:cNvPr id="6" name="text-29">
             <a:extLst xmlns:a="http://schemas.openxmlformats.org/drawingml/2006/main">
               <a:ext uri="{FF2B5EF4-FFF2-40B4-BE49-F238E27FC236}">
-                <a16:creationId xmlns:a16="http://schemas.microsoft.com/office/drawing/2014/main" id="{09C398DC-6139-469E-8160-FF2A78AD71F4}"/>
+                <a16:creationId xmlns:a16="http://schemas.microsoft.com/office/drawing/2014/main" id="{2967D640-E3E7-425D-82F3-7D6D4277D941}"/>
               </a:ext>
             </a:extLst>
           </p:cNvPr>
@@ -14135,7 +14135,7 @@
           <p:cNvPr id="7" name="text-30">
             <a:extLst xmlns:a="http://schemas.openxmlformats.org/drawingml/2006/main">
               <a:ext uri="{FF2B5EF4-FFF2-40B4-BE49-F238E27FC236}">
-                <a16:creationId xmlns:a16="http://schemas.microsoft.com/office/drawing/2014/main" id="{D4E3FF56-AE8F-4E63-B8B6-9AFD38D7675D}"/>
+                <a16:creationId xmlns:a16="http://schemas.microsoft.com/office/drawing/2014/main" id="{DD4D3406-4E0E-41D5-9239-D1701929350C}"/>
               </a:ext>
             </a:extLst>
           </p:cNvPr>
@@ -14339,7 +14339,7 @@
           <p:cNvPr id="8" name="text-31">
             <a:extLst xmlns:a="http://schemas.openxmlformats.org/drawingml/2006/main">
               <a:ext uri="{FF2B5EF4-FFF2-40B4-BE49-F238E27FC236}">
-                <a16:creationId xmlns:a16="http://schemas.microsoft.com/office/drawing/2014/main" id="{E81E8A65-22D0-42D5-9D62-3EE20B3A8054}"/>
+                <a16:creationId xmlns:a16="http://schemas.microsoft.com/office/drawing/2014/main" id="{C4E51D73-A5E2-48F6-B3B5-80BBC0D2642C}"/>
               </a:ext>
             </a:extLst>
           </p:cNvPr>
@@ -14497,7 +14497,7 @@
           <p:cNvPr id="9" name="text-32">
             <a:extLst xmlns:a="http://schemas.openxmlformats.org/drawingml/2006/main">
               <a:ext uri="{FF2B5EF4-FFF2-40B4-BE49-F238E27FC236}">
-                <a16:creationId xmlns:a16="http://schemas.microsoft.com/office/drawing/2014/main" id="{C12807B3-A65F-4E66-A145-F181F655D3DB}"/>
+                <a16:creationId xmlns:a16="http://schemas.microsoft.com/office/drawing/2014/main" id="{55986EF5-51BF-413C-8C69-D91607E286B4}"/>
               </a:ext>
             </a:extLst>
           </p:cNvPr>
@@ -14701,7 +14701,7 @@
           <p:cNvPr id="10" name="">
             <a:extLst xmlns:a="http://schemas.openxmlformats.org/drawingml/2006/main">
               <a:ext uri="{FF2B5EF4-FFF2-40B4-BE49-F238E27FC236}">
-                <a16:creationId xmlns:a16="http://schemas.microsoft.com/office/drawing/2014/main" id="{F79EB5F4-CD87-49A6-93A3-0B92C309B1A5}"/>
+                <a16:creationId xmlns:a16="http://schemas.microsoft.com/office/drawing/2014/main" id="{1A4EE1E4-9EE2-4889-9739-E3A8E86B8919}"/>
               </a:ext>
             </a:extLst>
           </p:cNvPr>
@@ -14711,7 +14711,7 @@
           <p:nvPr/>
         </p:nvPicPr>
         <p:blipFill>
-          <a:blip xmlns:r="http://schemas.openxmlformats.org/officeDocument/2006/relationships" xmlns:a="http://schemas.openxmlformats.org/drawingml/2006/main" r:embed="R460e1a6ba0cb4622"/>
+          <a:blip xmlns:r="http://schemas.openxmlformats.org/officeDocument/2006/relationships" xmlns:a="http://schemas.openxmlformats.org/drawingml/2006/main" r:embed="R38a855dd5ae04fb9"/>
           <a:srcRect xmlns:a="http://schemas.openxmlformats.org/drawingml/2006/main" l="63187" t="35329" r="3846" b="23353"/>
           <a:stretch xmlns:a="http://schemas.openxmlformats.org/drawingml/2006/main"/>
         </p:blipFill>
@@ -14728,7 +14728,7 @@
     </p:spTree>
     <p:extLst>
       <p:ext uri="{BB962C8B-B14F-4D97-AF65-F5344CB8AC3E}">
-        <p14:creationId xmlns:p14="http://schemas.microsoft.com/office/powerpoint/2010/main" val="1859955048"/>
+        <p14:creationId xmlns:p14="http://schemas.microsoft.com/office/powerpoint/2010/main" val="1846132813"/>
       </p:ext>
     </p:extLst>
   </p:cSld>
@@ -14759,7 +14759,7 @@
           <p:cNvPr id="10" name="text-33">
             <a:extLst xmlns:a="http://schemas.openxmlformats.org/drawingml/2006/main">
               <a:ext uri="{FF2B5EF4-FFF2-40B4-BE49-F238E27FC236}">
-                <a16:creationId xmlns:a16="http://schemas.microsoft.com/office/drawing/2014/main" id="{A264B6E7-E9D2-498F-AD5A-6EA211D9A787}"/>
+                <a16:creationId xmlns:a16="http://schemas.microsoft.com/office/drawing/2014/main" id="{078E2CB1-4813-4257-9AD2-B956627F0056}"/>
               </a:ext>
             </a:extLst>
           </p:cNvPr>
@@ -14917,7 +14917,7 @@
           <p:cNvPr id="2" name="text-34">
             <a:extLst xmlns:a="http://schemas.openxmlformats.org/drawingml/2006/main">
               <a:ext uri="{FF2B5EF4-FFF2-40B4-BE49-F238E27FC236}">
-                <a16:creationId xmlns:a16="http://schemas.microsoft.com/office/drawing/2014/main" id="{C674C93E-75E8-4D7B-85A0-EC37D32C008B}"/>
+                <a16:creationId xmlns:a16="http://schemas.microsoft.com/office/drawing/2014/main" id="{D7D85748-82B3-4770-873F-07225E2FAF49}"/>
               </a:ext>
             </a:extLst>
           </p:cNvPr>
@@ -15075,7 +15075,7 @@
           <p:cNvPr id="3" name="text-35">
             <a:extLst xmlns:a="http://schemas.openxmlformats.org/drawingml/2006/main">
               <a:ext uri="{FF2B5EF4-FFF2-40B4-BE49-F238E27FC236}">
-                <a16:creationId xmlns:a16="http://schemas.microsoft.com/office/drawing/2014/main" id="{6E9F4D77-BDA3-4DDB-9A37-95AF6B09AAD3}"/>
+                <a16:creationId xmlns:a16="http://schemas.microsoft.com/office/drawing/2014/main" id="{F882CBCE-AF4D-4A93-9123-E9DD7B053490}"/>
               </a:ext>
             </a:extLst>
           </p:cNvPr>
@@ -15233,7 +15233,7 @@
           <p:cNvPr id="4" name="text-36">
             <a:extLst xmlns:a="http://schemas.openxmlformats.org/drawingml/2006/main">
               <a:ext uri="{FF2B5EF4-FFF2-40B4-BE49-F238E27FC236}">
-                <a16:creationId xmlns:a16="http://schemas.microsoft.com/office/drawing/2014/main" id="{E4D43184-3456-40BF-866F-6C40AE1A5A12}"/>
+                <a16:creationId xmlns:a16="http://schemas.microsoft.com/office/drawing/2014/main" id="{82F7FF23-0046-49C3-9381-4F263D476483}"/>
               </a:ext>
             </a:extLst>
           </p:cNvPr>
@@ -15391,7 +15391,7 @@
           <p:cNvPr id="5" name="text-37">
             <a:extLst xmlns:a="http://schemas.openxmlformats.org/drawingml/2006/main">
               <a:ext uri="{FF2B5EF4-FFF2-40B4-BE49-F238E27FC236}">
-                <a16:creationId xmlns:a16="http://schemas.microsoft.com/office/drawing/2014/main" id="{5F808033-1B82-4DDA-8B11-269BC03243A6}"/>
+                <a16:creationId xmlns:a16="http://schemas.microsoft.com/office/drawing/2014/main" id="{9602763C-1848-439E-9E18-A1D1B6F5F70D}"/>
               </a:ext>
             </a:extLst>
           </p:cNvPr>
@@ -15595,7 +15595,7 @@
           <p:cNvPr id="6" name="text-38">
             <a:extLst xmlns:a="http://schemas.openxmlformats.org/drawingml/2006/main">
               <a:ext uri="{FF2B5EF4-FFF2-40B4-BE49-F238E27FC236}">
-                <a16:creationId xmlns:a16="http://schemas.microsoft.com/office/drawing/2014/main" id="{3512C2E1-3131-4588-9060-6289081ED679}"/>
+                <a16:creationId xmlns:a16="http://schemas.microsoft.com/office/drawing/2014/main" id="{39252B98-6D64-4E6C-B0F5-DD1D22E9E21D}"/>
               </a:ext>
             </a:extLst>
           </p:cNvPr>
@@ -15753,7 +15753,7 @@
           <p:cNvPr id="7" name="text-39">
             <a:extLst xmlns:a="http://schemas.openxmlformats.org/drawingml/2006/main">
               <a:ext uri="{FF2B5EF4-FFF2-40B4-BE49-F238E27FC236}">
-                <a16:creationId xmlns:a16="http://schemas.microsoft.com/office/drawing/2014/main" id="{ED2EA87D-7201-461F-9ECA-ECFD626645D7}"/>
+                <a16:creationId xmlns:a16="http://schemas.microsoft.com/office/drawing/2014/main" id="{4E57A43E-8B18-468D-B1F9-AF3A155B9A92}"/>
               </a:ext>
             </a:extLst>
           </p:cNvPr>
@@ -15957,7 +15957,7 @@
           <p:cNvPr id="8" name="text-40">
             <a:extLst xmlns:a="http://schemas.openxmlformats.org/drawingml/2006/main">
               <a:ext uri="{FF2B5EF4-FFF2-40B4-BE49-F238E27FC236}">
-                <a16:creationId xmlns:a16="http://schemas.microsoft.com/office/drawing/2014/main" id="{156D482C-A4D8-46D1-B24F-DAD8CC82DBE1}"/>
+                <a16:creationId xmlns:a16="http://schemas.microsoft.com/office/drawing/2014/main" id="{498AC16B-F066-4E35-BFB3-BDF15BA9EA64}"/>
               </a:ext>
             </a:extLst>
           </p:cNvPr>
@@ -16161,7 +16161,7 @@
           <p:cNvPr id="9" name="">
             <a:extLst xmlns:a="http://schemas.openxmlformats.org/drawingml/2006/main">
               <a:ext uri="{FF2B5EF4-FFF2-40B4-BE49-F238E27FC236}">
-                <a16:creationId xmlns:a16="http://schemas.microsoft.com/office/drawing/2014/main" id="{322C7C4B-8B78-4331-8D35-049B0C952CB6}"/>
+                <a16:creationId xmlns:a16="http://schemas.microsoft.com/office/drawing/2014/main" id="{8D32ACFD-86CD-449F-9FE6-9E0C47A6D453}"/>
               </a:ext>
             </a:extLst>
           </p:cNvPr>
@@ -16171,7 +16171,7 @@
           <p:nvPr/>
         </p:nvPicPr>
         <p:blipFill>
-          <a:blip xmlns:r="http://schemas.openxmlformats.org/officeDocument/2006/relationships" xmlns:a="http://schemas.openxmlformats.org/drawingml/2006/main" r:embed="R5311af47441f4e9e"/>
+          <a:blip xmlns:r="http://schemas.openxmlformats.org/officeDocument/2006/relationships" xmlns:a="http://schemas.openxmlformats.org/drawingml/2006/main" r:embed="R15030d785f0b412b"/>
           <a:srcRect xmlns:a="http://schemas.openxmlformats.org/drawingml/2006/main" l="0" t="0" r="0" b="0"/>
           <a:stretch xmlns:a="http://schemas.openxmlformats.org/drawingml/2006/main"/>
         </p:blipFill>
@@ -16188,7 +16188,7 @@
     </p:spTree>
     <p:extLst>
       <p:ext uri="{BB962C8B-B14F-4D97-AF65-F5344CB8AC3E}">
-        <p14:creationId xmlns:p14="http://schemas.microsoft.com/office/powerpoint/2010/main" val="1624493671"/>
+        <p14:creationId xmlns:p14="http://schemas.microsoft.com/office/powerpoint/2010/main" val="1626603539"/>
       </p:ext>
     </p:extLst>
   </p:cSld>
@@ -16219,7 +16219,7 @@
           <p:cNvPr id="13" name="text-41">
             <a:extLst xmlns:a="http://schemas.openxmlformats.org/drawingml/2006/main">
               <a:ext uri="{FF2B5EF4-FFF2-40B4-BE49-F238E27FC236}">
-                <a16:creationId xmlns:a16="http://schemas.microsoft.com/office/drawing/2014/main" id="{4D30FE3E-F5C9-4742-97D7-6696FA2E394D}"/>
+                <a16:creationId xmlns:a16="http://schemas.microsoft.com/office/drawing/2014/main" id="{C30A6496-DE81-4A6D-BF64-9D60EEA54F7C}"/>
               </a:ext>
             </a:extLst>
           </p:cNvPr>
@@ -16377,7 +16377,7 @@
           <p:cNvPr id="2" name="text-42">
             <a:extLst xmlns:a="http://schemas.openxmlformats.org/drawingml/2006/main">
               <a:ext uri="{FF2B5EF4-FFF2-40B4-BE49-F238E27FC236}">
-                <a16:creationId xmlns:a16="http://schemas.microsoft.com/office/drawing/2014/main" id="{59A69C86-FD31-4C11-96A7-F0ED35718692}"/>
+                <a16:creationId xmlns:a16="http://schemas.microsoft.com/office/drawing/2014/main" id="{02A642BB-158C-4A8A-91EF-78A2B11C9C0C}"/>
               </a:ext>
             </a:extLst>
           </p:cNvPr>
@@ -16535,7 +16535,7 @@
           <p:cNvPr id="3" name="text-43">
             <a:extLst xmlns:a="http://schemas.openxmlformats.org/drawingml/2006/main">
               <a:ext uri="{FF2B5EF4-FFF2-40B4-BE49-F238E27FC236}">
-                <a16:creationId xmlns:a16="http://schemas.microsoft.com/office/drawing/2014/main" id="{8E533C18-BC33-4CB3-9E59-4808B030D68B}"/>
+                <a16:creationId xmlns:a16="http://schemas.microsoft.com/office/drawing/2014/main" id="{E7CAD9C3-391C-4B26-8157-7AF7F3D4DAC8}"/>
               </a:ext>
             </a:extLst>
           </p:cNvPr>
@@ -16693,7 +16693,7 @@
           <p:cNvPr id="4" name="text-44">
             <a:extLst xmlns:a="http://schemas.openxmlformats.org/drawingml/2006/main">
               <a:ext uri="{FF2B5EF4-FFF2-40B4-BE49-F238E27FC236}">
-                <a16:creationId xmlns:a16="http://schemas.microsoft.com/office/drawing/2014/main" id="{169618E8-A0E0-458E-8F1F-E9320F12A8E3}"/>
+                <a16:creationId xmlns:a16="http://schemas.microsoft.com/office/drawing/2014/main" id="{E968E9F2-C7E0-46AD-A5EC-41CE00ACFB4E}"/>
               </a:ext>
             </a:extLst>
           </p:cNvPr>
@@ -16851,7 +16851,7 @@
           <p:cNvPr id="5" name="text-45">
             <a:extLst xmlns:a="http://schemas.openxmlformats.org/drawingml/2006/main">
               <a:ext uri="{FF2B5EF4-FFF2-40B4-BE49-F238E27FC236}">
-                <a16:creationId xmlns:a16="http://schemas.microsoft.com/office/drawing/2014/main" id="{2E8423F5-6F54-43FE-B4B7-C480BB3D2581}"/>
+                <a16:creationId xmlns:a16="http://schemas.microsoft.com/office/drawing/2014/main" id="{0D5CA4BF-A12E-44B9-8069-7B6586E4DAC8}"/>
               </a:ext>
             </a:extLst>
           </p:cNvPr>
@@ -17055,7 +17055,7 @@
           <p:cNvPr id="6" name="text-46">
             <a:extLst xmlns:a="http://schemas.openxmlformats.org/drawingml/2006/main">
               <a:ext uri="{FF2B5EF4-FFF2-40B4-BE49-F238E27FC236}">
-                <a16:creationId xmlns:a16="http://schemas.microsoft.com/office/drawing/2014/main" id="{548A4069-95E6-4D3F-99CD-894C79FD1F4D}"/>
+                <a16:creationId xmlns:a16="http://schemas.microsoft.com/office/drawing/2014/main" id="{DF4521AF-810E-4B47-AFE7-1437FAC67DDB}"/>
               </a:ext>
             </a:extLst>
           </p:cNvPr>
@@ -17213,7 +17213,7 @@
           <p:cNvPr id="7" name="text-47">
             <a:extLst xmlns:a="http://schemas.openxmlformats.org/drawingml/2006/main">
               <a:ext uri="{FF2B5EF4-FFF2-40B4-BE49-F238E27FC236}">
-                <a16:creationId xmlns:a16="http://schemas.microsoft.com/office/drawing/2014/main" id="{93DAF56A-77D8-4C87-8D34-191C5BE4C29B}"/>
+                <a16:creationId xmlns:a16="http://schemas.microsoft.com/office/drawing/2014/main" id="{45A887C3-3F4B-4D10-90ED-50BC225A194B}"/>
               </a:ext>
             </a:extLst>
           </p:cNvPr>
@@ -17417,7 +17417,7 @@
           <p:cNvPr id="8" name="text-48">
             <a:extLst xmlns:a="http://schemas.openxmlformats.org/drawingml/2006/main">
               <a:ext uri="{FF2B5EF4-FFF2-40B4-BE49-F238E27FC236}">
-                <a16:creationId xmlns:a16="http://schemas.microsoft.com/office/drawing/2014/main" id="{5B04BEAE-BD7D-4118-B794-64FD71F31BE1}"/>
+                <a16:creationId xmlns:a16="http://schemas.microsoft.com/office/drawing/2014/main" id="{0CEDD851-9A5B-4FBD-B9D4-DD33B2CFD452}"/>
               </a:ext>
             </a:extLst>
           </p:cNvPr>
@@ -17621,7 +17621,7 @@
           <p:cNvPr id="9" name="text-49">
             <a:extLst xmlns:a="http://schemas.openxmlformats.org/drawingml/2006/main">
               <a:ext uri="{FF2B5EF4-FFF2-40B4-BE49-F238E27FC236}">
-                <a16:creationId xmlns:a16="http://schemas.microsoft.com/office/drawing/2014/main" id="{E52C2133-FC65-43D0-8819-E91003A26886}"/>
+                <a16:creationId xmlns:a16="http://schemas.microsoft.com/office/drawing/2014/main" id="{A01B346D-D8C9-45FC-B704-A15DD6247EC8}"/>
               </a:ext>
             </a:extLst>
           </p:cNvPr>
@@ -17779,7 +17779,7 @@
           <p:cNvPr id="10" name="text-50">
             <a:extLst xmlns:a="http://schemas.openxmlformats.org/drawingml/2006/main">
               <a:ext uri="{FF2B5EF4-FFF2-40B4-BE49-F238E27FC236}">
-                <a16:creationId xmlns:a16="http://schemas.microsoft.com/office/drawing/2014/main" id="{EBD539AE-A225-4893-BA64-B9E5D718499D}"/>
+                <a16:creationId xmlns:a16="http://schemas.microsoft.com/office/drawing/2014/main" id="{BEAFACDF-EA79-488C-8E38-ACD9CACFE8BB}"/>
               </a:ext>
             </a:extLst>
           </p:cNvPr>
@@ -17937,7 +17937,7 @@
           <p:cNvPr id="11" name="">
             <a:extLst xmlns:a="http://schemas.openxmlformats.org/drawingml/2006/main">
               <a:ext uri="{FF2B5EF4-FFF2-40B4-BE49-F238E27FC236}">
-                <a16:creationId xmlns:a16="http://schemas.microsoft.com/office/drawing/2014/main" id="{2C720D61-49A8-4B37-8683-57F55022184B}"/>
+                <a16:creationId xmlns:a16="http://schemas.microsoft.com/office/drawing/2014/main" id="{25167D4A-3A5D-4860-B02A-BC72B72007DD}"/>
               </a:ext>
             </a:extLst>
           </p:cNvPr>
@@ -17947,7 +17947,7 @@
           <p:nvPr/>
         </p:nvPicPr>
         <p:blipFill>
-          <a:blip xmlns:r="http://schemas.openxmlformats.org/officeDocument/2006/relationships" xmlns:a="http://schemas.openxmlformats.org/drawingml/2006/main" r:embed="R3b9167c3602d46f5"/>
+          <a:blip xmlns:r="http://schemas.openxmlformats.org/officeDocument/2006/relationships" xmlns:a="http://schemas.openxmlformats.org/drawingml/2006/main" r:embed="R90f5821db0ef456e"/>
           <a:srcRect xmlns:a="http://schemas.openxmlformats.org/drawingml/2006/main" l="0" t="0" r="0" b="0"/>
           <a:stretch xmlns:a="http://schemas.openxmlformats.org/drawingml/2006/main"/>
         </p:blipFill>
@@ -17966,7 +17966,7 @@
           <p:cNvPr id="12" name="text-51">
             <a:extLst xmlns:a="http://schemas.openxmlformats.org/drawingml/2006/main">
               <a:ext uri="{FF2B5EF4-FFF2-40B4-BE49-F238E27FC236}">
-                <a16:creationId xmlns:a16="http://schemas.microsoft.com/office/drawing/2014/main" id="{7312CB41-CDCD-464D-A80B-489B1BDBDA3E}"/>
+                <a16:creationId xmlns:a16="http://schemas.microsoft.com/office/drawing/2014/main" id="{5638BA50-93BD-4404-9FED-EEDC6CA465DD}"/>
               </a:ext>
             </a:extLst>
           </p:cNvPr>
@@ -18122,7 +18122,7 @@
     </p:spTree>
     <p:extLst>
       <p:ext uri="{BB962C8B-B14F-4D97-AF65-F5344CB8AC3E}">
-        <p14:creationId xmlns:p14="http://schemas.microsoft.com/office/powerpoint/2010/main" val="459444778"/>
+        <p14:creationId xmlns:p14="http://schemas.microsoft.com/office/powerpoint/2010/main" val="2040619501"/>
       </p:ext>
     </p:extLst>
   </p:cSld>
@@ -18153,7 +18153,7 @@
           <p:cNvPr id="12" name="text-52">
             <a:extLst xmlns:a="http://schemas.openxmlformats.org/drawingml/2006/main">
               <a:ext uri="{FF2B5EF4-FFF2-40B4-BE49-F238E27FC236}">
-                <a16:creationId xmlns:a16="http://schemas.microsoft.com/office/drawing/2014/main" id="{8B4333DF-77B2-4ED3-9940-ED1ADC65EDBD}"/>
+                <a16:creationId xmlns:a16="http://schemas.microsoft.com/office/drawing/2014/main" id="{1017BBD9-8CEB-42D4-9CB4-2E9EE4741DCC}"/>
               </a:ext>
             </a:extLst>
           </p:cNvPr>
@@ -18301,7 +18301,7 @@
                 <a:ea typeface="Microsoft JhengHei"/>
                 <a:cs typeface="Microsoft JhengHei"/>
               </a:rPr>
-              <a:t>CGU 本機連線助手</a:t>
+              <a:t>CGU 瀏覽器直接連線</a:t>
             </a:r>
           </a:p>
         </p:txBody>
@@ -18311,7 +18311,7 @@
           <p:cNvPr id="2" name="text-53">
             <a:extLst xmlns:a="http://schemas.openxmlformats.org/drawingml/2006/main">
               <a:ext uri="{FF2B5EF4-FFF2-40B4-BE49-F238E27FC236}">
-                <a16:creationId xmlns:a16="http://schemas.microsoft.com/office/drawing/2014/main" id="{0AFDD9FD-F6D3-4D9F-9AFB-AA7D8FDCFE8C}"/>
+                <a16:creationId xmlns:a16="http://schemas.microsoft.com/office/drawing/2014/main" id="{72888E3F-C2A2-47B2-80CE-EA0286FD3AF9}"/>
               </a:ext>
             </a:extLst>
           </p:cNvPr>
@@ -18469,7 +18469,7 @@
           <p:cNvPr id="3" name="text-54">
             <a:extLst xmlns:a="http://schemas.openxmlformats.org/drawingml/2006/main">
               <a:ext uri="{FF2B5EF4-FFF2-40B4-BE49-F238E27FC236}">
-                <a16:creationId xmlns:a16="http://schemas.microsoft.com/office/drawing/2014/main" id="{1049A97E-F1A1-44AD-8F63-DB07E76EDF00}"/>
+                <a16:creationId xmlns:a16="http://schemas.microsoft.com/office/drawing/2014/main" id="{E42B4CCF-E8D6-48EA-BDA1-F6B29F600B2A}"/>
               </a:ext>
             </a:extLst>
           </p:cNvPr>
@@ -18627,7 +18627,7 @@
           <p:cNvPr id="4" name="text-55">
             <a:extLst xmlns:a="http://schemas.openxmlformats.org/drawingml/2006/main">
               <a:ext uri="{FF2B5EF4-FFF2-40B4-BE49-F238E27FC236}">
-                <a16:creationId xmlns:a16="http://schemas.microsoft.com/office/drawing/2014/main" id="{022A039A-9B45-4FFA-BAF6-A1EEBDE4F910}"/>
+                <a16:creationId xmlns:a16="http://schemas.microsoft.com/office/drawing/2014/main" id="{28F139B4-2D6A-4BB8-8845-04B29C9708BA}"/>
               </a:ext>
             </a:extLst>
           </p:cNvPr>
@@ -18775,7 +18775,7 @@
                 <a:ea typeface="Microsoft JhengHei"/>
                 <a:cs typeface="Microsoft JhengHei"/>
               </a:rPr>
-              <a:t>CGU 目前需透過自己的電腦轉送連線。</a:t>
+              <a:t>在「連接你的 AI」選 CGU API，即可由瀏覽器直接連線。</a:t>
             </a:r>
           </a:p>
         </p:txBody>
@@ -18785,7 +18785,7 @@
           <p:cNvPr id="5" name="text-56">
             <a:extLst xmlns:a="http://schemas.openxmlformats.org/drawingml/2006/main">
               <a:ext uri="{FF2B5EF4-FFF2-40B4-BE49-F238E27FC236}">
-                <a16:creationId xmlns:a16="http://schemas.microsoft.com/office/drawing/2014/main" id="{C7D1B061-432A-47EF-9028-4D0DBB75381E}"/>
+                <a16:creationId xmlns:a16="http://schemas.microsoft.com/office/drawing/2014/main" id="{83B674AA-9E25-4CD1-AF6C-2F87CC123B48}"/>
               </a:ext>
             </a:extLst>
           </p:cNvPr>
@@ -18933,7 +18933,7 @@
                 <a:ea typeface="Microsoft JhengHei"/>
                 <a:cs typeface="Microsoft JhengHei"/>
               </a:rPr>
-              <a:t>1. 下載並啟動助手</a:t>
+              <a:t>1. 貼上並驗證金鑰</a:t>
             </a:r>
           </a:p>
         </p:txBody>
@@ -18943,7 +18943,7 @@
           <p:cNvPr id="6" name="text-57">
             <a:extLst xmlns:a="http://schemas.openxmlformats.org/drawingml/2006/main">
               <a:ext uri="{FF2B5EF4-FFF2-40B4-BE49-F238E27FC236}">
-                <a16:creationId xmlns:a16="http://schemas.microsoft.com/office/drawing/2014/main" id="{F5684AAF-DA4F-4580-A45F-BB7B8AEEFAB8}"/>
+                <a16:creationId xmlns:a16="http://schemas.microsoft.com/office/drawing/2014/main" id="{298CBAB7-CCC1-4E4C-AFD0-B2C2184BF57A}"/>
               </a:ext>
             </a:extLst>
           </p:cNvPr>
@@ -19091,7 +19091,7 @@
                 <a:ea typeface="Microsoft JhengHei"/>
                 <a:cs typeface="Microsoft JhengHei"/>
               </a:rPr>
-              <a:t>安裝 Node.js 24 或更新版，</a:t>
+              <a:t>貼上自己的 CGU API key，</a:t>
             </a:r>
           </a:p>
           <a:p xmlns:a="http://schemas.openxmlformats.org/drawingml/2006/main">
@@ -19114,7 +19114,7 @@
                 <a:ea typeface="Microsoft JhengHei"/>
                 <a:cs typeface="Microsoft JhengHei"/>
               </a:rPr>
-              <a:t>在 CGU 設定下載本機助手。</a:t>
+              <a:t>按「驗證 CGU 金鑰」。</a:t>
             </a:r>
           </a:p>
           <a:p xmlns:a="http://schemas.openxmlformats.org/drawingml/2006/main">
@@ -19137,7 +19137,7 @@
                 <a:ea typeface="Microsoft JhengHei"/>
                 <a:cs typeface="Microsoft JhengHei"/>
               </a:rPr>
-              <a:t>在下載資料夾執行下方指令。</a:t>
+              <a:t>這一步只查詢模型清單。</a:t>
             </a:r>
           </a:p>
         </p:txBody>
@@ -19147,7 +19147,7 @@
           <p:cNvPr id="7" name="text-58">
             <a:extLst xmlns:a="http://schemas.openxmlformats.org/drawingml/2006/main">
               <a:ext uri="{FF2B5EF4-FFF2-40B4-BE49-F238E27FC236}">
-                <a16:creationId xmlns:a16="http://schemas.microsoft.com/office/drawing/2014/main" id="{8E6AA1BD-D144-4EF9-80C1-362AEA04E5B2}"/>
+                <a16:creationId xmlns:a16="http://schemas.microsoft.com/office/drawing/2014/main" id="{9B0C32B7-1F12-4373-A37D-ABEA2E3C60E6}"/>
               </a:ext>
             </a:extLst>
           </p:cNvPr>
@@ -19295,7 +19295,7 @@
                 <a:ea typeface="Microsoft JhengHei"/>
                 <a:cs typeface="Microsoft JhengHei"/>
               </a:rPr>
-              <a:t>2. 配對與驗證</a:t>
+              <a:t>2. 選擇模型並測試</a:t>
             </a:r>
           </a:p>
         </p:txBody>
@@ -19305,7 +19305,7 @@
           <p:cNvPr id="8" name="text-59">
             <a:extLst xmlns:a="http://schemas.openxmlformats.org/drawingml/2006/main">
               <a:ext uri="{FF2B5EF4-FFF2-40B4-BE49-F238E27FC236}">
-                <a16:creationId xmlns:a16="http://schemas.microsoft.com/office/drawing/2014/main" id="{F8323A4C-5A37-48AD-86C7-692E5D668FE5}"/>
+                <a16:creationId xmlns:a16="http://schemas.microsoft.com/office/drawing/2014/main" id="{2141F1B4-C9F8-49A0-9FB9-8E0C0C9B5518}"/>
               </a:ext>
             </a:extLst>
           </p:cNvPr>
@@ -19453,7 +19453,7 @@
                 <a:ea typeface="Microsoft JhengHei"/>
                 <a:cs typeface="Microsoft JhengHei"/>
               </a:rPr>
-              <a:t>保持終端機開啟，貼上</a:t>
+              <a:t>選擇模型與推理程度，</a:t>
             </a:r>
           </a:p>
           <a:p xmlns:a="http://schemas.openxmlformats.org/drawingml/2006/main">
@@ -19476,7 +19476,7 @@
                 <a:ea typeface="Microsoft JhengHei"/>
                 <a:cs typeface="Microsoft JhengHei"/>
               </a:rPr>
-              <a:t>Pairing code 並連接助手。</a:t>
+              <a:t>按「測試連線」確認文字生成。</a:t>
             </a:r>
           </a:p>
           <a:p xmlns:a="http://schemas.openxmlformats.org/drawingml/2006/main">
@@ -19499,7 +19499,7 @@
                 <a:ea typeface="Microsoft JhengHei"/>
                 <a:cs typeface="Microsoft JhengHei"/>
               </a:rPr>
-              <a:t>再填 CGU 金鑰並驗證。</a:t>
+              <a:t>測試會使用少量額度。</a:t>
             </a:r>
           </a:p>
         </p:txBody>
@@ -19509,7 +19509,7 @@
           <p:cNvPr id="9" name="text-60">
             <a:extLst xmlns:a="http://schemas.openxmlformats.org/drawingml/2006/main">
               <a:ext uri="{FF2B5EF4-FFF2-40B4-BE49-F238E27FC236}">
-                <a16:creationId xmlns:a16="http://schemas.microsoft.com/office/drawing/2014/main" id="{2CA91FA5-8339-4202-9232-5C1DC29EB329}"/>
+                <a16:creationId xmlns:a16="http://schemas.microsoft.com/office/drawing/2014/main" id="{E84C41D5-B54E-4523-8FA2-DFBE70DF88E0}"/>
               </a:ext>
             </a:extLst>
           </p:cNvPr>
@@ -19657,7 +19657,7 @@
                 <a:ea typeface="Microsoft JhengHei"/>
                 <a:cs typeface="Microsoft JhengHei"/>
               </a:rPr>
-              <a:t>啟動指令：node PaperReader-CGU-Bridge.mjs</a:t>
+              <a:t>金鑰與文字以 HTTPS 直接傳給 CGU。</a:t>
             </a:r>
           </a:p>
         </p:txBody>
@@ -19667,7 +19667,7 @@
           <p:cNvPr id="10" name="text-61">
             <a:extLst xmlns:a="http://schemas.openxmlformats.org/drawingml/2006/main">
               <a:ext uri="{FF2B5EF4-FFF2-40B4-BE49-F238E27FC236}">
-                <a16:creationId xmlns:a16="http://schemas.microsoft.com/office/drawing/2014/main" id="{42194DAB-6BFB-41C8-9AFE-A5F30528045C}"/>
+                <a16:creationId xmlns:a16="http://schemas.microsoft.com/office/drawing/2014/main" id="{244C706D-07B0-4324-9204-3F7379EF11D1}"/>
               </a:ext>
             </a:extLst>
           </p:cNvPr>
@@ -19815,7 +19815,7 @@
                 <a:ea typeface="Microsoft JhengHei"/>
                 <a:cs typeface="Microsoft JhengHei"/>
               </a:rPr>
-              <a:t>若瀏覽器詢問本機網路權限，請允許。</a:t>
+              <a:t>模型清單為教學示例；實際可用模型依帳戶而定。</a:t>
             </a:r>
           </a:p>
         </p:txBody>
@@ -19825,7 +19825,7 @@
           <p:cNvPr id="11" name="">
             <a:extLst xmlns:a="http://schemas.openxmlformats.org/drawingml/2006/main">
               <a:ext uri="{FF2B5EF4-FFF2-40B4-BE49-F238E27FC236}">
-                <a16:creationId xmlns:a16="http://schemas.microsoft.com/office/drawing/2014/main" id="{F5EB0A4D-AD1F-4C14-9B78-5A8885A5BA59}"/>
+                <a16:creationId xmlns:a16="http://schemas.microsoft.com/office/drawing/2014/main" id="{F7920AF0-A448-41A9-B878-D99C45E737A4}"/>
               </a:ext>
             </a:extLst>
           </p:cNvPr>
@@ -19835,14 +19835,14 @@
           <p:nvPr/>
         </p:nvPicPr>
         <p:blipFill>
-          <a:blip xmlns:r="http://schemas.openxmlformats.org/officeDocument/2006/relationships" xmlns:a="http://schemas.openxmlformats.org/drawingml/2006/main" r:embed="R00590fae99424e14"/>
+          <a:blip xmlns:r="http://schemas.openxmlformats.org/officeDocument/2006/relationships" xmlns:a="http://schemas.openxmlformats.org/drawingml/2006/main" r:embed="Rd48a517992bb4246"/>
           <a:srcRect xmlns:a="http://schemas.openxmlformats.org/drawingml/2006/main" l="0" t="0" r="0" b="0"/>
           <a:stretch xmlns:a="http://schemas.openxmlformats.org/drawingml/2006/main"/>
         </p:blipFill>
         <p:spPr>
           <a:xfrm xmlns:a="http://schemas.openxmlformats.org/drawingml/2006/main">
-            <a:off x="7342717" y="2028825"/>
-            <a:ext cx="5640917" cy="4953000"/>
+            <a:off x="6263399" y="2028825"/>
+            <a:ext cx="7799552" cy="4953000"/>
           </a:xfrm>
           <a:prstGeom xmlns:a="http://schemas.openxmlformats.org/drawingml/2006/main" prst="rect">
             <a:avLst/>
@@ -19852,7 +19852,7 @@
     </p:spTree>
     <p:extLst>
       <p:ext uri="{BB962C8B-B14F-4D97-AF65-F5344CB8AC3E}">
-        <p14:creationId xmlns:p14="http://schemas.microsoft.com/office/powerpoint/2010/main" val="869260688"/>
+        <p14:creationId xmlns:p14="http://schemas.microsoft.com/office/powerpoint/2010/main" val="2092156874"/>
       </p:ext>
     </p:extLst>
   </p:cSld>
@@ -19883,7 +19883,7 @@
           <p:cNvPr id="11" name="text-62">
             <a:extLst xmlns:a="http://schemas.openxmlformats.org/drawingml/2006/main">
               <a:ext uri="{FF2B5EF4-FFF2-40B4-BE49-F238E27FC236}">
-                <a16:creationId xmlns:a16="http://schemas.microsoft.com/office/drawing/2014/main" id="{09842BB7-676C-43E6-B380-0D17ECD3FF23}"/>
+                <a16:creationId xmlns:a16="http://schemas.microsoft.com/office/drawing/2014/main" id="{BB14BA49-45CA-4E39-A633-2A43839C3E38}"/>
               </a:ext>
             </a:extLst>
           </p:cNvPr>
@@ -20041,7 +20041,7 @@
           <p:cNvPr id="2" name="text-63">
             <a:extLst xmlns:a="http://schemas.openxmlformats.org/drawingml/2006/main">
               <a:ext uri="{FF2B5EF4-FFF2-40B4-BE49-F238E27FC236}">
-                <a16:creationId xmlns:a16="http://schemas.microsoft.com/office/drawing/2014/main" id="{6310CA1A-453E-4FD4-B2AB-B79D2F38EE82}"/>
+                <a16:creationId xmlns:a16="http://schemas.microsoft.com/office/drawing/2014/main" id="{A5200F00-C659-4FB1-9621-E29A40F27BD9}"/>
               </a:ext>
             </a:extLst>
           </p:cNvPr>
@@ -20199,7 +20199,7 @@
           <p:cNvPr id="3" name="text-64">
             <a:extLst xmlns:a="http://schemas.openxmlformats.org/drawingml/2006/main">
               <a:ext uri="{FF2B5EF4-FFF2-40B4-BE49-F238E27FC236}">
-                <a16:creationId xmlns:a16="http://schemas.microsoft.com/office/drawing/2014/main" id="{D64B1A99-83F5-49D8-8E5A-2BDB83607839}"/>
+                <a16:creationId xmlns:a16="http://schemas.microsoft.com/office/drawing/2014/main" id="{FA5BE4F3-F0A3-4413-87B6-31CD43DA8C8C}"/>
               </a:ext>
             </a:extLst>
           </p:cNvPr>
@@ -20357,7 +20357,7 @@
           <p:cNvPr id="4" name="text-65">
             <a:extLst xmlns:a="http://schemas.openxmlformats.org/drawingml/2006/main">
               <a:ext uri="{FF2B5EF4-FFF2-40B4-BE49-F238E27FC236}">
-                <a16:creationId xmlns:a16="http://schemas.microsoft.com/office/drawing/2014/main" id="{0B450DC8-37F7-47EC-AC4A-A0557CAD8478}"/>
+                <a16:creationId xmlns:a16="http://schemas.microsoft.com/office/drawing/2014/main" id="{569D464E-7B22-48CB-A904-4181C1F75E99}"/>
               </a:ext>
             </a:extLst>
           </p:cNvPr>
@@ -20515,7 +20515,7 @@
           <p:cNvPr id="5" name="text-66">
             <a:extLst xmlns:a="http://schemas.openxmlformats.org/drawingml/2006/main">
               <a:ext uri="{FF2B5EF4-FFF2-40B4-BE49-F238E27FC236}">
-                <a16:creationId xmlns:a16="http://schemas.microsoft.com/office/drawing/2014/main" id="{27A5F85D-A8D8-4545-972B-AF4EFAD8E9A0}"/>
+                <a16:creationId xmlns:a16="http://schemas.microsoft.com/office/drawing/2014/main" id="{B1485152-9116-4ABC-9660-4BD5E7A251EC}"/>
               </a:ext>
             </a:extLst>
           </p:cNvPr>
@@ -20719,7 +20719,7 @@
           <p:cNvPr id="6" name="text-67">
             <a:extLst xmlns:a="http://schemas.openxmlformats.org/drawingml/2006/main">
               <a:ext uri="{FF2B5EF4-FFF2-40B4-BE49-F238E27FC236}">
-                <a16:creationId xmlns:a16="http://schemas.microsoft.com/office/drawing/2014/main" id="{A148E695-6277-4A33-9885-C3F5FCA2087D}"/>
+                <a16:creationId xmlns:a16="http://schemas.microsoft.com/office/drawing/2014/main" id="{70C065D2-61D2-44DF-A5B7-F212B1DD93E8}"/>
               </a:ext>
             </a:extLst>
           </p:cNvPr>
@@ -20877,7 +20877,7 @@
           <p:cNvPr id="7" name="text-68">
             <a:extLst xmlns:a="http://schemas.openxmlformats.org/drawingml/2006/main">
               <a:ext uri="{FF2B5EF4-FFF2-40B4-BE49-F238E27FC236}">
-                <a16:creationId xmlns:a16="http://schemas.microsoft.com/office/drawing/2014/main" id="{3C12056B-36AB-4B3C-B9BC-8A8FE853724A}"/>
+                <a16:creationId xmlns:a16="http://schemas.microsoft.com/office/drawing/2014/main" id="{B8CFAA66-C5B4-4E97-9AEA-411EEDF64186}"/>
               </a:ext>
             </a:extLst>
           </p:cNvPr>
@@ -21081,7 +21081,7 @@
           <p:cNvPr id="8" name="text-69">
             <a:extLst xmlns:a="http://schemas.openxmlformats.org/drawingml/2006/main">
               <a:ext uri="{FF2B5EF4-FFF2-40B4-BE49-F238E27FC236}">
-                <a16:creationId xmlns:a16="http://schemas.microsoft.com/office/drawing/2014/main" id="{E9A09745-B776-43C1-9D30-1EAAF4D148FF}"/>
+                <a16:creationId xmlns:a16="http://schemas.microsoft.com/office/drawing/2014/main" id="{BB24EF1A-E3F0-4BCA-8EC9-F47ED1DD3678}"/>
               </a:ext>
             </a:extLst>
           </p:cNvPr>
@@ -21262,7 +21262,7 @@
           <p:cNvPr id="9" name="">
             <a:extLst xmlns:a="http://schemas.openxmlformats.org/drawingml/2006/main">
               <a:ext uri="{FF2B5EF4-FFF2-40B4-BE49-F238E27FC236}">
-                <a16:creationId xmlns:a16="http://schemas.microsoft.com/office/drawing/2014/main" id="{B5E55C16-9F82-49E7-91E6-27D58C5CA08A}"/>
+                <a16:creationId xmlns:a16="http://schemas.microsoft.com/office/drawing/2014/main" id="{79271CC4-946D-47DE-BA55-A953D93AA031}"/>
               </a:ext>
             </a:extLst>
           </p:cNvPr>
@@ -21272,14 +21272,14 @@
           <p:nvPr/>
         </p:nvPicPr>
         <p:blipFill>
-          <a:blip xmlns:r="http://schemas.openxmlformats.org/officeDocument/2006/relationships" xmlns:a="http://schemas.openxmlformats.org/drawingml/2006/main" r:embed="Rbe1af88441b84e2a"/>
+          <a:blip xmlns:r="http://schemas.openxmlformats.org/officeDocument/2006/relationships" xmlns:a="http://schemas.openxmlformats.org/drawingml/2006/main" r:embed="R8c454a35c5eb46e3"/>
           <a:srcRect xmlns:a="http://schemas.openxmlformats.org/drawingml/2006/main" l="0" t="0" r="0" b="0"/>
           <a:stretch xmlns:a="http://schemas.openxmlformats.org/drawingml/2006/main"/>
         </p:blipFill>
         <p:spPr>
           <a:xfrm xmlns:a="http://schemas.openxmlformats.org/drawingml/2006/main">
-            <a:off x="7199188" y="1971675"/>
-            <a:ext cx="5880350" cy="5286375"/>
+            <a:off x="7200847" y="1971675"/>
+            <a:ext cx="5877031" cy="5286375"/>
           </a:xfrm>
           <a:prstGeom xmlns:a="http://schemas.openxmlformats.org/drawingml/2006/main" prst="rect">
             <a:avLst/>
@@ -21291,7 +21291,7 @@
           <p:cNvPr id="10" name="text-70">
             <a:extLst xmlns:a="http://schemas.openxmlformats.org/drawingml/2006/main">
               <a:ext uri="{FF2B5EF4-FFF2-40B4-BE49-F238E27FC236}">
-                <a16:creationId xmlns:a16="http://schemas.microsoft.com/office/drawing/2014/main" id="{4636E8C4-DC39-4146-BD33-87D24BE35B8C}"/>
+                <a16:creationId xmlns:a16="http://schemas.microsoft.com/office/drawing/2014/main" id="{E2F09109-050C-4E88-91CC-06D22BFA84FB}"/>
               </a:ext>
             </a:extLst>
           </p:cNvPr>
@@ -21447,7 +21447,7 @@
     </p:spTree>
     <p:extLst>
       <p:ext uri="{BB962C8B-B14F-4D97-AF65-F5344CB8AC3E}">
-        <p14:creationId xmlns:p14="http://schemas.microsoft.com/office/powerpoint/2010/main" val="309728885"/>
+        <p14:creationId xmlns:p14="http://schemas.microsoft.com/office/powerpoint/2010/main" val="1786928350"/>
       </p:ext>
     </p:extLst>
   </p:cSld>
@@ -21478,7 +21478,7 @@
           <p:cNvPr id="11" name="text-71">
             <a:extLst xmlns:a="http://schemas.openxmlformats.org/drawingml/2006/main">
               <a:ext uri="{FF2B5EF4-FFF2-40B4-BE49-F238E27FC236}">
-                <a16:creationId xmlns:a16="http://schemas.microsoft.com/office/drawing/2014/main" id="{D546B2A3-25E7-473B-A333-582F0E47BA7F}"/>
+                <a16:creationId xmlns:a16="http://schemas.microsoft.com/office/drawing/2014/main" id="{087E3B2C-76A0-45BA-BB34-A04E6869E4E3}"/>
               </a:ext>
             </a:extLst>
           </p:cNvPr>
@@ -21636,7 +21636,7 @@
           <p:cNvPr id="2" name="text-72">
             <a:extLst xmlns:a="http://schemas.openxmlformats.org/drawingml/2006/main">
               <a:ext uri="{FF2B5EF4-FFF2-40B4-BE49-F238E27FC236}">
-                <a16:creationId xmlns:a16="http://schemas.microsoft.com/office/drawing/2014/main" id="{A4710655-45E9-4F18-BE63-DDE995F1721B}"/>
+                <a16:creationId xmlns:a16="http://schemas.microsoft.com/office/drawing/2014/main" id="{842FED91-DE06-47FA-84F8-C3EED188C24B}"/>
               </a:ext>
             </a:extLst>
           </p:cNvPr>
@@ -21794,7 +21794,7 @@
           <p:cNvPr id="3" name="text-73">
             <a:extLst xmlns:a="http://schemas.openxmlformats.org/drawingml/2006/main">
               <a:ext uri="{FF2B5EF4-FFF2-40B4-BE49-F238E27FC236}">
-                <a16:creationId xmlns:a16="http://schemas.microsoft.com/office/drawing/2014/main" id="{647E1AC7-74B6-402B-8377-DBA27B64AE4B}"/>
+                <a16:creationId xmlns:a16="http://schemas.microsoft.com/office/drawing/2014/main" id="{10D9A5A5-24F8-46AA-887D-20FF8A43A229}"/>
               </a:ext>
             </a:extLst>
           </p:cNvPr>
@@ -21952,7 +21952,7 @@
           <p:cNvPr id="4" name="text-74">
             <a:extLst xmlns:a="http://schemas.openxmlformats.org/drawingml/2006/main">
               <a:ext uri="{FF2B5EF4-FFF2-40B4-BE49-F238E27FC236}">
-                <a16:creationId xmlns:a16="http://schemas.microsoft.com/office/drawing/2014/main" id="{747398F6-942B-4A3D-B159-9211C80FF874}"/>
+                <a16:creationId xmlns:a16="http://schemas.microsoft.com/office/drawing/2014/main" id="{F4B84754-28CA-420E-AFEE-C4546A70C976}"/>
               </a:ext>
             </a:extLst>
           </p:cNvPr>
@@ -22110,7 +22110,7 @@
           <p:cNvPr id="5" name="text-75">
             <a:extLst xmlns:a="http://schemas.openxmlformats.org/drawingml/2006/main">
               <a:ext uri="{FF2B5EF4-FFF2-40B4-BE49-F238E27FC236}">
-                <a16:creationId xmlns:a16="http://schemas.microsoft.com/office/drawing/2014/main" id="{D112F5E5-5AE6-412E-9774-1D131F26DAAE}"/>
+                <a16:creationId xmlns:a16="http://schemas.microsoft.com/office/drawing/2014/main" id="{ED2600DE-C783-4833-86DF-50860F5DC521}"/>
               </a:ext>
             </a:extLst>
           </p:cNvPr>
@@ -22314,7 +22314,7 @@
           <p:cNvPr id="6" name="text-76">
             <a:extLst xmlns:a="http://schemas.openxmlformats.org/drawingml/2006/main">
               <a:ext uri="{FF2B5EF4-FFF2-40B4-BE49-F238E27FC236}">
-                <a16:creationId xmlns:a16="http://schemas.microsoft.com/office/drawing/2014/main" id="{A4D70C32-416C-466D-A3D2-C83BDDCED29F}"/>
+                <a16:creationId xmlns:a16="http://schemas.microsoft.com/office/drawing/2014/main" id="{FDDCE8EC-8DFD-48DB-BE12-39C00142AA9F}"/>
               </a:ext>
             </a:extLst>
           </p:cNvPr>
@@ -22472,7 +22472,7 @@
           <p:cNvPr id="7" name="text-77">
             <a:extLst xmlns:a="http://schemas.openxmlformats.org/drawingml/2006/main">
               <a:ext uri="{FF2B5EF4-FFF2-40B4-BE49-F238E27FC236}">
-                <a16:creationId xmlns:a16="http://schemas.microsoft.com/office/drawing/2014/main" id="{5E1C0775-0D50-4DAE-A1C4-960E52757943}"/>
+                <a16:creationId xmlns:a16="http://schemas.microsoft.com/office/drawing/2014/main" id="{7623EFF0-4536-4478-BA66-DE003E117F6D}"/>
               </a:ext>
             </a:extLst>
           </p:cNvPr>
@@ -22676,7 +22676,7 @@
           <p:cNvPr id="8" name="text-78">
             <a:extLst xmlns:a="http://schemas.openxmlformats.org/drawingml/2006/main">
               <a:ext uri="{FF2B5EF4-FFF2-40B4-BE49-F238E27FC236}">
-                <a16:creationId xmlns:a16="http://schemas.microsoft.com/office/drawing/2014/main" id="{F8719B81-5F2E-4B27-9CCE-A0ADF4A47895}"/>
+                <a16:creationId xmlns:a16="http://schemas.microsoft.com/office/drawing/2014/main" id="{2AB4F756-2EA9-4A70-A136-B607DA483857}"/>
               </a:ext>
             </a:extLst>
           </p:cNvPr>
@@ -22880,7 +22880,7 @@
           <p:cNvPr id="9" name="">
             <a:extLst xmlns:a="http://schemas.openxmlformats.org/drawingml/2006/main">
               <a:ext uri="{FF2B5EF4-FFF2-40B4-BE49-F238E27FC236}">
-                <a16:creationId xmlns:a16="http://schemas.microsoft.com/office/drawing/2014/main" id="{B71312F9-9CBE-4FD8-8804-D297D9982D36}"/>
+                <a16:creationId xmlns:a16="http://schemas.microsoft.com/office/drawing/2014/main" id="{C63ECA98-A5E0-4876-9CC1-789C317C7100}"/>
               </a:ext>
             </a:extLst>
           </p:cNvPr>
@@ -22890,7 +22890,7 @@
           <p:nvPr/>
         </p:nvPicPr>
         <p:blipFill>
-          <a:blip xmlns:r="http://schemas.openxmlformats.org/officeDocument/2006/relationships" xmlns:a="http://schemas.openxmlformats.org/drawingml/2006/main" r:embed="Ra03eb376bec5413c"/>
+          <a:blip xmlns:r="http://schemas.openxmlformats.org/officeDocument/2006/relationships" xmlns:a="http://schemas.openxmlformats.org/drawingml/2006/main" r:embed="Reafee4fd7c2448ce"/>
           <a:srcRect xmlns:a="http://schemas.openxmlformats.org/drawingml/2006/main" l="2273" t="15013" r="2273" b="36684"/>
           <a:stretch xmlns:a="http://schemas.openxmlformats.org/drawingml/2006/main"/>
         </p:blipFill>
@@ -22909,7 +22909,7 @@
           <p:cNvPr id="10" name="">
             <a:extLst xmlns:a="http://schemas.openxmlformats.org/drawingml/2006/main">
               <a:ext uri="{FF2B5EF4-FFF2-40B4-BE49-F238E27FC236}">
-                <a16:creationId xmlns:a16="http://schemas.microsoft.com/office/drawing/2014/main" id="{4CE0862B-C472-45B9-B721-7D416138EECF}"/>
+                <a16:creationId xmlns:a16="http://schemas.microsoft.com/office/drawing/2014/main" id="{5E3B0817-EB30-4C69-9A24-261F4329DDA0}"/>
               </a:ext>
             </a:extLst>
           </p:cNvPr>
@@ -22919,7 +22919,7 @@
           <p:nvPr/>
         </p:nvPicPr>
         <p:blipFill>
-          <a:blip xmlns:r="http://schemas.openxmlformats.org/officeDocument/2006/relationships" xmlns:a="http://schemas.openxmlformats.org/drawingml/2006/main" r:embed="Rad5668aa67624628"/>
+          <a:blip xmlns:r="http://schemas.openxmlformats.org/officeDocument/2006/relationships" xmlns:a="http://schemas.openxmlformats.org/drawingml/2006/main" r:embed="R6591930c582d4233"/>
           <a:srcRect xmlns:a="http://schemas.openxmlformats.org/drawingml/2006/main" l="2273" t="91057" r="2273" b="1762"/>
           <a:stretch xmlns:a="http://schemas.openxmlformats.org/drawingml/2006/main"/>
         </p:blipFill>
@@ -22936,7 +22936,7 @@
     </p:spTree>
     <p:extLst>
       <p:ext uri="{BB962C8B-B14F-4D97-AF65-F5344CB8AC3E}">
-        <p14:creationId xmlns:p14="http://schemas.microsoft.com/office/powerpoint/2010/main" val="864347940"/>
+        <p14:creationId xmlns:p14="http://schemas.microsoft.com/office/powerpoint/2010/main" val="2000465089"/>
       </p:ext>
     </p:extLst>
   </p:cSld>

</xml_diff>